<commit_message>
Add Professional Services recommendations slide to Seaboard EA deck
Insert slide 10 before Next Steps with tiered PS recommendations
mapped to EA scope (Secure Access, Meraki, ThousandEyes, identity,
SD-WAN) and Support Customer Value framework attach motions.

Co-authored-by: chchilds <chchilds@users.noreply.github.com>
</commit_message>
<xml_diff>
--- a/Seaboard_Foods_EA_Summary.pptx
+++ b/Seaboard_Foods_EA_Summary.pptx
@@ -14,6 +14,7 @@
     <p:sldId id="262" r:id="rId13"/>
     <p:sldId id="263" r:id="rId14"/>
     <p:sldId id="264" r:id="rId15"/>
+    <p:sldId id="266" r:id="rId17"/>
     <p:sldId id="265" r:id="rId16"/>
   </p:sldIdLst>
   <p:sldSz cx="12191695" cy="6858000" type="screen4x3"/>
@@ -3726,6 +3727,498 @@
             </a:pPr>
             <a:r>
               <a:t>Cisco Confidential | Indicative Pricing Only</a:t>
+            </a:r>
+          </a:p>
+        </p:txBody>
+      </p:sp>
+    </p:spTree>
+  </p:cSld>
+  <p:clrMapOvr>
+    <a:masterClrMapping/>
+  </p:clrMapOvr>
+</p:sld>
+</file>
+
+<file path=ppt/slides/slide11.xml><?xml version="1.0" encoding="utf-8"?>
+<p:sld xmlns:a="http://schemas.openxmlformats.org/drawingml/2006/main" xmlns:p="http://schemas.openxmlformats.org/presentationml/2006/main" xmlns:r="http://schemas.openxmlformats.org/officeDocument/2006/relationships">
+  <p:cSld>
+    <p:spTree>
+      <p:nvGrpSpPr>
+        <p:cNvPr id="1" name=""/>
+        <p:cNvGrpSpPr/>
+        <p:nvPr/>
+      </p:nvGrpSpPr>
+      <p:grpSpPr/>
+      <p:sp>
+        <p:nvSpPr>
+          <p:cNvPr id="2" name="Rectangle 1"/>
+          <p:cNvSpPr/>
+          <p:nvPr/>
+        </p:nvSpPr>
+        <p:spPr>
+          <a:xfrm>
+            <a:off x="0" y="0"/>
+            <a:ext cx="12191695" cy="1097280"/>
+          </a:xfrm>
+          <a:prstGeom prst="rect">
+            <a:avLst/>
+          </a:prstGeom>
+          <a:solidFill>
+            <a:srgbClr val="007BC7"/>
+          </a:solidFill>
+          <a:ln>
+            <a:noFill/>
+          </a:ln>
+        </p:spPr>
+        <p:style>
+          <a:lnRef idx="1">
+            <a:schemeClr val="accent1"/>
+          </a:lnRef>
+          <a:fillRef idx="3">
+            <a:schemeClr val="accent1"/>
+          </a:fillRef>
+          <a:effectRef idx="2">
+            <a:schemeClr val="accent1"/>
+          </a:effectRef>
+          <a:fontRef idx="minor">
+            <a:schemeClr val="lt1"/>
+          </a:fontRef>
+        </p:style>
+        <p:txBody>
+          <a:bodyPr rtlCol="0" anchor="ctr"/>
+          <a:lstStyle/>
+          <a:p>
+            <a:pPr algn="ctr"/>
+          </a:p>
+        </p:txBody>
+      </p:sp>
+      <p:sp>
+        <p:nvSpPr>
+          <p:cNvPr id="3" name="TextBox 2"/>
+          <p:cNvSpPr txBox="1"/>
+          <p:nvPr/>
+        </p:nvSpPr>
+        <p:spPr>
+          <a:xfrm>
+            <a:off x="548640" y="228600"/>
+            <a:ext cx="10972800" cy="640080"/>
+          </a:xfrm>
+          <a:prstGeom prst="rect">
+            <a:avLst/>
+          </a:prstGeom>
+          <a:noFill/>
+        </p:spPr>
+        <p:txBody>
+          <a:bodyPr wrap="none">
+            <a:spAutoFit/>
+          </a:bodyPr>
+          <a:lstStyle/>
+          <a:p>
+            <a:pPr>
+              <a:defRPr sz="3200" b="1">
+                <a:solidFill>
+                  <a:srgbClr val="FFFFFF"/>
+                </a:solidFill>
+              </a:defRPr>
+            </a:pPr>
+            <a:r>
+              <a:rPr b="1" sz="2800">
+                <a:solidFill>
+                  <a:srgbClr val="FFFFFF"/>
+                </a:solidFill>
+              </a:rPr>
+              <a:t>Recommended Professional Services</a:t>
+            </a:r>
+          </a:p>
+        </p:txBody>
+      </p:sp>
+      <p:sp>
+        <p:nvSpPr>
+          <p:cNvPr id="4" name="TextBox 3"/>
+          <p:cNvSpPr txBox="1"/>
+          <p:nvPr/>
+        </p:nvSpPr>
+        <p:spPr>
+          <a:xfrm>
+            <a:off x="731520" y="1463040"/>
+            <a:ext cx="10515600" cy="5029200"/>
+          </a:xfrm>
+          <a:prstGeom prst="rect">
+            <a:avLst/>
+          </a:prstGeom>
+          <a:noFill/>
+        </p:spPr>
+        <p:txBody>
+          <a:bodyPr wrap="square">
+            <a:spAutoFit/>
+          </a:bodyPr>
+          <a:lstStyle/>
+          <a:p>
+            <a:pPr>
+              <a:spcAft>
+                <a:spcPts val="800"/>
+              </a:spcAft>
+              <a:defRPr sz="1800">
+                <a:solidFill>
+                  <a:srgbClr val="333333"/>
+                </a:solidFill>
+              </a:defRPr>
+            </a:pPr>
+            <a:r>
+              <a:rPr b="1" sz="1200">
+                <a:solidFill>
+                  <a:srgbClr val="007BC7"/>
+                </a:solidFill>
+              </a:rPr>
+              <a:t>Context</a:t>
+            </a:r>
+          </a:p>
+          <a:p>
+            <a:pPr>
+              <a:spcBef>
+                <a:spcPts val="200"/>
+              </a:spcBef>
+            </a:pPr>
+            <a:r>
+              <a:rPr sz="1000">
+                <a:solidFill>
+                  <a:srgbClr val="333333"/>
+                </a:solidFill>
+              </a:rPr>
+              <a:t>• Professional Services are not included in Proposal 9305711 (~$1.24M support is in scope).</a:t>
+            </a:r>
+          </a:p>
+          <a:p>
+            <a:pPr>
+              <a:spcBef>
+                <a:spcPts val="200"/>
+              </a:spcBef>
+            </a:pPr>
+            <a:r>
+              <a:rPr sz="1000">
+                <a:solidFill>
+                  <a:srgbClr val="333333"/>
+                </a:solidFill>
+              </a:rPr>
+              <a:t>• Recommendations align EA portfolios with Cisco Support / PS lifecycle: Activate → Integrate → Optimize.</a:t>
+            </a:r>
+          </a:p>
+          <a:p>
+            <a:pPr>
+              <a:spcBef>
+                <a:spcPts val="600"/>
+              </a:spcBef>
+            </a:pPr>
+            <a:r>
+              <a:rPr b="1" sz="1200">
+                <a:solidFill>
+                  <a:srgbClr val="007BC7"/>
+                </a:solidFill>
+              </a:rPr>
+              <a:t>Tier 1 — EA Activation (Must-Have)</a:t>
+            </a:r>
+          </a:p>
+          <a:p>
+            <a:pPr>
+              <a:spcBef>
+                <a:spcPts val="200"/>
+              </a:spcBef>
+            </a:pPr>
+            <a:r>
+              <a:rPr sz="1000">
+                <a:solidFill>
+                  <a:srgbClr val="333333"/>
+                </a:solidFill>
+              </a:rPr>
+              <a:t>• Enterprise Agreement Management Support (included with Services EA purchase)</a:t>
+            </a:r>
+          </a:p>
+          <a:p>
+            <a:pPr>
+              <a:spcBef>
+                <a:spcPts val="200"/>
+              </a:spcBef>
+            </a:pPr>
+            <a:r>
+              <a:rPr sz="1000">
+                <a:solidFill>
+                  <a:srgbClr val="333333"/>
+                </a:solidFill>
+              </a:rPr>
+              <a:t>• Install Base Assessment &amp; Entitlement Reconciliation</a:t>
+            </a:r>
+          </a:p>
+          <a:p>
+            <a:pPr>
+              <a:spcBef>
+                <a:spcPts val="200"/>
+              </a:spcBef>
+            </a:pPr>
+            <a:r>
+              <a:rPr sz="1000">
+                <a:solidFill>
+                  <a:srgbClr val="333333"/>
+                </a:solidFill>
+              </a:rPr>
+              <a:t>• EA Activation &amp; License Consumption Planning (pre-EA assets consumed at activation)</a:t>
+            </a:r>
+          </a:p>
+          <a:p>
+            <a:pPr>
+              <a:spcBef>
+                <a:spcPts val="600"/>
+              </a:spcBef>
+            </a:pPr>
+            <a:r>
+              <a:rPr b="1" sz="1200">
+                <a:solidFill>
+                  <a:srgbClr val="007BC7"/>
+                </a:solidFill>
+              </a:rPr>
+              <a:t>Tier 2 — Highest EA Impact</a:t>
+            </a:r>
+          </a:p>
+          <a:p>
+            <a:pPr>
+              <a:spcBef>
+                <a:spcPts val="200"/>
+              </a:spcBef>
+            </a:pPr>
+            <a:r>
+              <a:rPr sz="1000">
+                <a:solidFill>
+                  <a:srgbClr val="333333"/>
+                </a:solidFill>
+              </a:rPr>
+              <a:t>• Secure Access (SASE) Plan, Design &amp; Implement — 3,000 users ($691K SSE software)</a:t>
+            </a:r>
+          </a:p>
+          <a:p>
+            <a:pPr>
+              <a:spcBef>
+                <a:spcPts val="200"/>
+              </a:spcBef>
+            </a:pPr>
+            <a:r>
+              <a:rPr sz="1000">
+                <a:solidFill>
+                  <a:srgbClr val="333333"/>
+                </a:solidFill>
+              </a:rPr>
+              <a:t>• Meraki At-Scale Deployment &amp; Optimization — 609 APs, 150 switches, 56 MX</a:t>
+            </a:r>
+          </a:p>
+          <a:p>
+            <a:pPr>
+              <a:spcBef>
+                <a:spcPts val="200"/>
+              </a:spcBef>
+            </a:pPr>
+            <a:r>
+              <a:rPr sz="1000">
+                <a:solidFill>
+                  <a:srgbClr val="333333"/>
+                </a:solidFill>
+              </a:rPr>
+              <a:t>• Meraki ↔ Secure Access SASE Integration (MX 19.1+, Security Cloud Control)</a:t>
+            </a:r>
+          </a:p>
+          <a:p>
+            <a:pPr>
+              <a:spcBef>
+                <a:spcPts val="200"/>
+              </a:spcBef>
+            </a:pPr>
+            <a:r>
+              <a:rPr sz="1000">
+                <a:solidFill>
+                  <a:srgbClr val="333333"/>
+                </a:solidFill>
+              </a:rPr>
+              <a:t>• Catalyst / Nexus DNA EA Onboarding &amp; Automation</a:t>
+            </a:r>
+          </a:p>
+          <a:p>
+            <a:pPr>
+              <a:spcBef>
+                <a:spcPts val="600"/>
+              </a:spcBef>
+            </a:pPr>
+            <a:r>
+              <a:rPr b="1" sz="1200">
+                <a:solidFill>
+                  <a:srgbClr val="007BC7"/>
+                </a:solidFill>
+              </a:rPr>
+              <a:t>Tier 3 — Security &amp; Observability</a:t>
+            </a:r>
+          </a:p>
+          <a:p>
+            <a:pPr>
+              <a:spcBef>
+                <a:spcPts val="200"/>
+              </a:spcBef>
+            </a:pPr>
+            <a:r>
+              <a:rPr sz="1000">
+                <a:solidFill>
+                  <a:srgbClr val="333333"/>
+                </a:solidFill>
+              </a:rPr>
+              <a:t>• Duo + ISE Zero Trust PDI (2,500 / 8,000) | Secure Firewall FTD PDI (45 devices)</a:t>
+            </a:r>
+          </a:p>
+          <a:p>
+            <a:pPr>
+              <a:spcBef>
+                <a:spcPts val="200"/>
+              </a:spcBef>
+            </a:pPr>
+            <a:r>
+              <a:rPr sz="1000">
+                <a:solidFill>
+                  <a:srgbClr val="333333"/>
+                </a:solidFill>
+              </a:rPr>
+              <a:t>• ThousandEyes Deployment — 4,000 agents (+1,500 net new)</a:t>
+            </a:r>
+          </a:p>
+          <a:p>
+            <a:pPr>
+              <a:spcBef>
+                <a:spcPts val="200"/>
+              </a:spcBef>
+            </a:pPr>
+            <a:r>
+              <a:rPr sz="1000">
+                <a:solidFill>
+                  <a:srgbClr val="333333"/>
+                </a:solidFill>
+              </a:rPr>
+              <a:t>• SD-WAN / ENTWAN Plan, Design &amp; Implement</a:t>
+            </a:r>
+          </a:p>
+          <a:p>
+            <a:pPr>
+              <a:spcBef>
+                <a:spcPts val="600"/>
+              </a:spcBef>
+            </a:pPr>
+            <a:r>
+              <a:rPr b="1" sz="1200">
+                <a:solidFill>
+                  <a:srgbClr val="007BC7"/>
+                </a:solidFill>
+              </a:rPr>
+              <a:t>Support &amp; Enablement (Customer Value Framework)</a:t>
+            </a:r>
+          </a:p>
+          <a:p>
+            <a:pPr>
+              <a:spcBef>
+                <a:spcPts val="200"/>
+              </a:spcBef>
+            </a:pPr>
+            <a:r>
+              <a:rPr sz="1000">
+                <a:solidFill>
+                  <a:srgbClr val="333333"/>
+                </a:solidFill>
+              </a:rPr>
+              <a:t>• Add Services EA wrapper for unified renewal | Signature Support for critical campus/DC</a:t>
+            </a:r>
+          </a:p>
+          <a:p>
+            <a:pPr>
+              <a:spcBef>
+                <a:spcPts val="200"/>
+              </a:spcBef>
+            </a:pPr>
+            <a:r>
+              <a:rPr sz="1000">
+                <a:solidFill>
+                  <a:srgbClr val="333333"/>
+                </a:solidFill>
+              </a:rPr>
+              <a:t>• Standard Support for Secure Access, Duo, ISE, ThousandEyes | Cisco Learning Credits for ops teams</a:t>
+            </a:r>
+          </a:p>
+          <a:p>
+            <a:pPr>
+              <a:spcBef>
+                <a:spcPts val="600"/>
+              </a:spcBef>
+            </a:pPr>
+            <a:r>
+              <a:rPr b="1" sz="1200">
+                <a:solidFill>
+                  <a:srgbClr val="007BC7"/>
+                </a:solidFill>
+              </a:rPr>
+              <a:t>Suggested Starter Bundle</a:t>
+            </a:r>
+          </a:p>
+          <a:p>
+            <a:pPr>
+              <a:spcBef>
+                <a:spcPts val="200"/>
+              </a:spcBef>
+            </a:pPr>
+            <a:r>
+              <a:rPr sz="1000">
+                <a:solidFill>
+                  <a:srgbClr val="333333"/>
+                </a:solidFill>
+              </a:rPr>
+              <a:t>• EA Activation + Secure Access PDI + Meraki Deployment + ThousandEyes + CLCs</a:t>
+            </a:r>
+          </a:p>
+          <a:p>
+            <a:pPr>
+              <a:spcBef>
+                <a:spcPts val="200"/>
+              </a:spcBef>
+            </a:pPr>
+            <a:r>
+              <a:rPr sz="1000">
+                <a:solidFill>
+                  <a:srgbClr val="333333"/>
+                </a:solidFill>
+              </a:rPr>
+              <a:t>• Optional: Talos Incident Response Retainer for distributed manufacturing sites</a:t>
+            </a:r>
+          </a:p>
+        </p:txBody>
+      </p:sp>
+      <p:sp>
+        <p:nvSpPr>
+          <p:cNvPr id="5" name="TextBox 4"/>
+          <p:cNvSpPr txBox="1"/>
+          <p:nvPr/>
+        </p:nvSpPr>
+        <p:spPr>
+          <a:xfrm>
+            <a:off x="457200" y="6400800"/>
+            <a:ext cx="10972800" cy="365760"/>
+          </a:xfrm>
+          <a:prstGeom prst="rect">
+            <a:avLst/>
+          </a:prstGeom>
+          <a:noFill/>
+        </p:spPr>
+        <p:txBody>
+          <a:bodyPr wrap="none">
+            <a:spAutoFit/>
+          </a:bodyPr>
+          <a:lstStyle/>
+          <a:p>
+            <a:r>
+              <a:rPr sz="900" i="1">
+                <a:solidFill>
+                  <a:srgbClr val="666666"/>
+                </a:solidFill>
+              </a:rPr>
+              <a:t>Cisco Confidential | Indicative PS Recommendations — Not a formal quote</a:t>
             </a:r>
           </a:p>
         </p:txBody>

</xml_diff>

<commit_message>
Apply dark theme to all PPTX slides
- Add pptx/theme.py with Cisco dark color palette
- Add pptx/apply_dark_theme.py to convert decks to dark theme
- Update Seaboard_Foods_EA_Summary.pptx: all 11 slides now use
  dark navy backgrounds with light body text, dark table rows,
  and updated Office theme color scheme

Co-authored-by: chchilds <chchilds@users.noreply.github.com>
</commit_message>
<xml_diff>
--- a/Seaboard_Foods_EA_Summary.pptx
+++ b/Seaboard_Foods_EA_Summary.pptx
@@ -3265,6 +3265,9 @@
               </a:defRPr>
             </a:pPr>
             <a:r>
+              <a:rPr>
+                <a:solidFill/>
+              </a:rPr>
               <a:t>Seaboard Foods LLC</a:t>
             </a:r>
           </a:p>
@@ -3300,10 +3303,16 @@
               </a:defRPr>
             </a:pPr>
             <a:r>
+              <a:rPr>
+                <a:solidFill/>
+              </a:rPr>
               <a:t>Cisco Enterprise Agreement</a:t>
             </a:r>
             <a:br/>
             <a:r>
+              <a:rPr>
+                <a:solidFill/>
+              </a:rPr>
               <a:t>Price Estimate Summary</a:t>
             </a:r>
           </a:p>
@@ -3339,6 +3348,9 @@
               </a:defRPr>
             </a:pPr>
             <a:r>
+              <a:rPr>
+                <a:solidFill/>
+              </a:rPr>
               <a:t>Proposal ID: 9305711</a:t>
             </a:r>
           </a:p>
@@ -3351,6 +3363,9 @@
               </a:defRPr>
             </a:pPr>
             <a:r>
+              <a:rPr>
+                <a:solidFill/>
+              </a:rPr>
               <a:t>Project: Seaboard CX EA</a:t>
             </a:r>
           </a:p>
@@ -3363,6 +3378,9 @@
               </a:defRPr>
             </a:pPr>
             <a:r>
+              <a:rPr>
+                <a:solidFill/>
+              </a:rPr>
               <a:t>Expected Book Date: August 4, 2026</a:t>
             </a:r>
           </a:p>
@@ -3375,6 +3393,9 @@
               </a:defRPr>
             </a:pPr>
             <a:r>
+              <a:rPr>
+                <a:solidFill/>
+              </a:rPr>
               <a:t>36-Month Term | Annual Billing</a:t>
             </a:r>
           </a:p>
@@ -3387,6 +3408,9 @@
               </a:defRPr>
             </a:pPr>
             <a:r>
+              <a:rPr>
+                <a:solidFill/>
+              </a:rPr>
               <a:t>Report Date: July 7, 2026</a:t>
             </a:r>
           </a:p>
@@ -3417,11 +3441,14 @@
             <a:pPr algn="ctr">
               <a:defRPr sz="900">
                 <a:solidFill>
-                  <a:srgbClr val="666666"/>
-                </a:solidFill>
-              </a:defRPr>
-            </a:pPr>
-            <a:r>
+                  <a:srgbClr val="999999"/>
+                </a:solidFill>
+              </a:defRPr>
+            </a:pPr>
+            <a:r>
+              <a:rPr>
+                <a:solidFill/>
+              </a:rPr>
               <a:t>CISCO CONFIDENTIAL — Indicative pricing only. Not an approved Cisco quote.</a:t>
             </a:r>
           </a:p>
@@ -3438,6 +3465,14 @@
 <file path=ppt/slides/slide10.xml><?xml version="1.0" encoding="utf-8"?>
 <p:sld xmlns:a="http://schemas.openxmlformats.org/drawingml/2006/main" xmlns:p="http://schemas.openxmlformats.org/presentationml/2006/main" xmlns:r="http://schemas.openxmlformats.org/officeDocument/2006/relationships">
   <p:cSld>
+    <p:bg>
+      <p:bgPr>
+        <a:solidFill>
+          <a:srgbClr val="1A2B4A"/>
+        </a:solidFill>
+        <a:effectLst/>
+      </p:bgPr>
+    </p:bg>
     <p:spTree>
       <p:nvGrpSpPr>
         <p:cNvPr id="1" name=""/>
@@ -3518,7 +3553,12 @@
               </a:defRPr>
             </a:pPr>
             <a:r>
-              <a:t>Next Steps &amp; Important Notes</a:t>
+              <a:rPr b="1" sz="2800">
+                <a:solidFill>
+                  <a:srgbClr val="FFFFFF"/>
+                </a:solidFill>
+              </a:rPr>
+              <a:t>Recommended Professional Services</a:t>
             </a:r>
           </a:p>
         </p:txBody>
@@ -3549,149 +3589,334 @@
               <a:spcAft>
                 <a:spcPts val="800"/>
               </a:spcAft>
-              <a:defRPr sz="1500">
-                <a:solidFill>
-                  <a:srgbClr val="333333"/>
-                </a:solidFill>
-              </a:defRPr>
-            </a:pPr>
-            <a:r>
-              <a:t>Important Disclaimers</a:t>
-            </a:r>
-          </a:p>
-          <a:p>
-            <a:pPr>
-              <a:spcAft>
-                <a:spcPts val="800"/>
-              </a:spcAft>
-              <a:defRPr sz="1500">
-                <a:solidFill>
-                  <a:srgbClr val="333333"/>
-                </a:solidFill>
-              </a:defRPr>
-            </a:pPr>
-            <a:r>
-              <a:t>This is indicative pricing only — NOT an approved Cisco quote</a:t>
-            </a:r>
-          </a:p>
-          <a:p>
-            <a:pPr>
-              <a:spcAft>
-                <a:spcPts val="800"/>
-              </a:spcAft>
-              <a:defRPr sz="1500">
-                <a:solidFill>
-                  <a:srgbClr val="333333"/>
-                </a:solidFill>
-              </a:defRPr>
-            </a:pPr>
-            <a:r>
-              <a:t>Pricing is subject to change until formal quote approval</a:t>
-            </a:r>
-          </a:p>
-          <a:p>
-            <a:pPr>
-              <a:spcAft>
-                <a:spcPts val="800"/>
-              </a:spcAft>
-              <a:defRPr sz="1500">
-                <a:solidFill>
-                  <a:srgbClr val="333333"/>
-                </a:solidFill>
-              </a:defRPr>
-            </a:pPr>
-            <a:r>
-              <a:t>Pre-EA install base licenses will be consumed at EA activation</a:t>
-            </a:r>
-          </a:p>
-          <a:p>
-            <a:pPr>
-              <a:spcAft>
-                <a:spcPts val="800"/>
-              </a:spcAft>
-              <a:defRPr sz="1500">
-                <a:solidFill>
-                  <a:srgbClr val="333333"/>
-                </a:solidFill>
-              </a:defRPr>
-            </a:pPr>
-            <a:r>
-              <a:t>Recommended Actions</a:t>
-            </a:r>
-          </a:p>
-          <a:p>
-            <a:pPr>
-              <a:spcAft>
-                <a:spcPts val="800"/>
-              </a:spcAft>
-              <a:defRPr sz="1500">
-                <a:solidFill>
-                  <a:srgbClr val="333333"/>
-                </a:solidFill>
-              </a:defRPr>
-            </a:pPr>
-            <a:r>
-              <a:t>Review portfolio quantities against current install base</a:t>
-            </a:r>
-          </a:p>
-          <a:p>
-            <a:pPr>
-              <a:spcAft>
-                <a:spcPts val="800"/>
-              </a:spcAft>
-              <a:defRPr sz="1500">
-                <a:solidFill>
-                  <a:srgbClr val="333333"/>
-                </a:solidFill>
-              </a:defRPr>
-            </a:pPr>
-            <a:r>
-              <a:t>Validate Meraki (609 APs) and Secure Access (3,000 user) counts</a:t>
-            </a:r>
-          </a:p>
-          <a:p>
-            <a:pPr>
-              <a:spcAft>
-                <a:spcPts val="800"/>
-              </a:spcAft>
-              <a:defRPr sz="1500">
-                <a:solidFill>
-                  <a:srgbClr val="333333"/>
-                </a:solidFill>
-              </a:defRPr>
-            </a:pPr>
-            <a:r>
-              <a:t>Confirm support coverage levels (8x5xNBD vs 24x7x4) meet SLA requirements</a:t>
-            </a:r>
-          </a:p>
-          <a:p>
-            <a:pPr>
-              <a:spcAft>
-                <a:spcPts val="800"/>
-              </a:spcAft>
-              <a:defRPr sz="1500">
-                <a:solidFill>
-                  <a:srgbClr val="333333"/>
-                </a:solidFill>
-              </a:defRPr>
-            </a:pPr>
-            <a:r>
-              <a:t>Work with CDW and Cisco AM Robin Randolph to finalize quote</a:t>
-            </a:r>
-          </a:p>
-          <a:p>
-            <a:pPr>
-              <a:spcAft>
-                <a:spcPts val="800"/>
-              </a:spcAft>
-              <a:defRPr sz="1500">
-                <a:solidFill>
-                  <a:srgbClr val="333333"/>
-                </a:solidFill>
-              </a:defRPr>
-            </a:pPr>
-            <a:r>
-              <a:t>EA Proposal Link: apps.cisco.com/ea/project/proposal/9305711</a:t>
+              <a:defRPr sz="1800">
+                <a:solidFill>
+                  <a:srgbClr val="E0E0E0"/>
+                </a:solidFill>
+              </a:defRPr>
+            </a:pPr>
+            <a:r>
+              <a:rPr b="1" sz="1200">
+                <a:solidFill>
+                  <a:srgbClr val="007BC7"/>
+                </a:solidFill>
+              </a:rPr>
+              <a:t>Context</a:t>
+            </a:r>
+          </a:p>
+          <a:p>
+            <a:pPr>
+              <a:spcBef>
+                <a:spcPts val="200"/>
+              </a:spcBef>
+            </a:pPr>
+            <a:r>
+              <a:rPr sz="1000">
+                <a:solidFill>
+                  <a:srgbClr val="E0E0E0"/>
+                </a:solidFill>
+              </a:rPr>
+              <a:t>• Professional Services are not included in Proposal 9305711 (~$1.24M support is in scope).</a:t>
+            </a:r>
+          </a:p>
+          <a:p>
+            <a:pPr>
+              <a:spcBef>
+                <a:spcPts val="200"/>
+              </a:spcBef>
+            </a:pPr>
+            <a:r>
+              <a:rPr sz="1000">
+                <a:solidFill>
+                  <a:srgbClr val="E0E0E0"/>
+                </a:solidFill>
+              </a:rPr>
+              <a:t>• Recommendations align EA portfolios with Cisco Support / PS lifecycle: Activate → Integrate → Optimize.</a:t>
+            </a:r>
+          </a:p>
+          <a:p>
+            <a:pPr>
+              <a:spcBef>
+                <a:spcPts val="600"/>
+              </a:spcBef>
+            </a:pPr>
+            <a:r>
+              <a:rPr b="1" sz="1200">
+                <a:solidFill>
+                  <a:srgbClr val="007BC7"/>
+                </a:solidFill>
+              </a:rPr>
+              <a:t>Tier 1 — EA Activation (Must-Have)</a:t>
+            </a:r>
+          </a:p>
+          <a:p>
+            <a:pPr>
+              <a:spcBef>
+                <a:spcPts val="200"/>
+              </a:spcBef>
+            </a:pPr>
+            <a:r>
+              <a:rPr sz="1000">
+                <a:solidFill>
+                  <a:srgbClr val="E0E0E0"/>
+                </a:solidFill>
+              </a:rPr>
+              <a:t>• Enterprise Agreement Management Support (included with Services EA purchase)</a:t>
+            </a:r>
+          </a:p>
+          <a:p>
+            <a:pPr>
+              <a:spcBef>
+                <a:spcPts val="200"/>
+              </a:spcBef>
+            </a:pPr>
+            <a:r>
+              <a:rPr sz="1000">
+                <a:solidFill>
+                  <a:srgbClr val="E0E0E0"/>
+                </a:solidFill>
+              </a:rPr>
+              <a:t>• Install Base Assessment &amp; Entitlement Reconciliation</a:t>
+            </a:r>
+          </a:p>
+          <a:p>
+            <a:pPr>
+              <a:spcBef>
+                <a:spcPts val="200"/>
+              </a:spcBef>
+            </a:pPr>
+            <a:r>
+              <a:rPr sz="1000">
+                <a:solidFill>
+                  <a:srgbClr val="E0E0E0"/>
+                </a:solidFill>
+              </a:rPr>
+              <a:t>• EA Activation &amp; License Consumption Planning (pre-EA assets consumed at activation)</a:t>
+            </a:r>
+          </a:p>
+          <a:p>
+            <a:pPr>
+              <a:spcBef>
+                <a:spcPts val="600"/>
+              </a:spcBef>
+            </a:pPr>
+            <a:r>
+              <a:rPr b="1" sz="1200">
+                <a:solidFill>
+                  <a:srgbClr val="007BC7"/>
+                </a:solidFill>
+              </a:rPr>
+              <a:t>Tier 2 — Highest EA Impact</a:t>
+            </a:r>
+          </a:p>
+          <a:p>
+            <a:pPr>
+              <a:spcBef>
+                <a:spcPts val="200"/>
+              </a:spcBef>
+            </a:pPr>
+            <a:r>
+              <a:rPr sz="1000">
+                <a:solidFill>
+                  <a:srgbClr val="E0E0E0"/>
+                </a:solidFill>
+              </a:rPr>
+              <a:t>• Secure Access (SASE) Plan, Design &amp; Implement — 3,000 users ($691K SSE software)</a:t>
+            </a:r>
+          </a:p>
+          <a:p>
+            <a:pPr>
+              <a:spcBef>
+                <a:spcPts val="200"/>
+              </a:spcBef>
+            </a:pPr>
+            <a:r>
+              <a:rPr sz="1000">
+                <a:solidFill>
+                  <a:srgbClr val="E0E0E0"/>
+                </a:solidFill>
+              </a:rPr>
+              <a:t>• Meraki At-Scale Deployment &amp; Optimization — 609 APs, 150 switches, 56 MX</a:t>
+            </a:r>
+          </a:p>
+          <a:p>
+            <a:pPr>
+              <a:spcBef>
+                <a:spcPts val="200"/>
+              </a:spcBef>
+            </a:pPr>
+            <a:r>
+              <a:rPr sz="1000">
+                <a:solidFill>
+                  <a:srgbClr val="E0E0E0"/>
+                </a:solidFill>
+              </a:rPr>
+              <a:t>• Meraki ↔ Secure Access SASE Integration (MX 19.1+, Security Cloud Control)</a:t>
+            </a:r>
+          </a:p>
+          <a:p>
+            <a:pPr>
+              <a:spcBef>
+                <a:spcPts val="200"/>
+              </a:spcBef>
+            </a:pPr>
+            <a:r>
+              <a:rPr sz="1000">
+                <a:solidFill>
+                  <a:srgbClr val="E0E0E0"/>
+                </a:solidFill>
+              </a:rPr>
+              <a:t>• Catalyst / Nexus DNA EA Onboarding &amp; Automation</a:t>
+            </a:r>
+          </a:p>
+          <a:p>
+            <a:pPr>
+              <a:spcBef>
+                <a:spcPts val="600"/>
+              </a:spcBef>
+            </a:pPr>
+            <a:r>
+              <a:rPr b="1" sz="1200">
+                <a:solidFill>
+                  <a:srgbClr val="007BC7"/>
+                </a:solidFill>
+              </a:rPr>
+              <a:t>Tier 3 — Security &amp; Observability</a:t>
+            </a:r>
+          </a:p>
+          <a:p>
+            <a:pPr>
+              <a:spcBef>
+                <a:spcPts val="200"/>
+              </a:spcBef>
+            </a:pPr>
+            <a:r>
+              <a:rPr sz="1000">
+                <a:solidFill>
+                  <a:srgbClr val="E0E0E0"/>
+                </a:solidFill>
+              </a:rPr>
+              <a:t>• Duo + ISE Zero Trust PDI (2,500 / 8,000) | Secure Firewall FTD PDI (45 devices)</a:t>
+            </a:r>
+          </a:p>
+          <a:p>
+            <a:pPr>
+              <a:spcBef>
+                <a:spcPts val="200"/>
+              </a:spcBef>
+            </a:pPr>
+            <a:r>
+              <a:rPr sz="1000">
+                <a:solidFill>
+                  <a:srgbClr val="E0E0E0"/>
+                </a:solidFill>
+              </a:rPr>
+              <a:t>• ThousandEyes Deployment — 4,000 agents (+1,500 net new)</a:t>
+            </a:r>
+          </a:p>
+          <a:p>
+            <a:pPr>
+              <a:spcBef>
+                <a:spcPts val="200"/>
+              </a:spcBef>
+            </a:pPr>
+            <a:r>
+              <a:rPr sz="1000">
+                <a:solidFill>
+                  <a:srgbClr val="E0E0E0"/>
+                </a:solidFill>
+              </a:rPr>
+              <a:t>• SD-WAN / ENTWAN Plan, Design &amp; Implement</a:t>
+            </a:r>
+          </a:p>
+          <a:p>
+            <a:pPr>
+              <a:spcBef>
+                <a:spcPts val="600"/>
+              </a:spcBef>
+            </a:pPr>
+            <a:r>
+              <a:rPr b="1" sz="1200">
+                <a:solidFill>
+                  <a:srgbClr val="007BC7"/>
+                </a:solidFill>
+              </a:rPr>
+              <a:t>Support &amp; Enablement (Customer Value Framework)</a:t>
+            </a:r>
+          </a:p>
+          <a:p>
+            <a:pPr>
+              <a:spcBef>
+                <a:spcPts val="200"/>
+              </a:spcBef>
+            </a:pPr>
+            <a:r>
+              <a:rPr sz="1000">
+                <a:solidFill>
+                  <a:srgbClr val="E0E0E0"/>
+                </a:solidFill>
+              </a:rPr>
+              <a:t>• Add Services EA wrapper for unified renewal | Signature Support for critical campus/DC</a:t>
+            </a:r>
+          </a:p>
+          <a:p>
+            <a:pPr>
+              <a:spcBef>
+                <a:spcPts val="200"/>
+              </a:spcBef>
+            </a:pPr>
+            <a:r>
+              <a:rPr sz="1000">
+                <a:solidFill>
+                  <a:srgbClr val="E0E0E0"/>
+                </a:solidFill>
+              </a:rPr>
+              <a:t>• Standard Support for Secure Access, Duo, ISE, ThousandEyes | Cisco Learning Credits for ops teams</a:t>
+            </a:r>
+          </a:p>
+          <a:p>
+            <a:pPr>
+              <a:spcBef>
+                <a:spcPts val="600"/>
+              </a:spcBef>
+            </a:pPr>
+            <a:r>
+              <a:rPr b="1" sz="1200">
+                <a:solidFill>
+                  <a:srgbClr val="007BC7"/>
+                </a:solidFill>
+              </a:rPr>
+              <a:t>Suggested Starter Bundle</a:t>
+            </a:r>
+          </a:p>
+          <a:p>
+            <a:pPr>
+              <a:spcBef>
+                <a:spcPts val="200"/>
+              </a:spcBef>
+            </a:pPr>
+            <a:r>
+              <a:rPr sz="1000">
+                <a:solidFill>
+                  <a:srgbClr val="E0E0E0"/>
+                </a:solidFill>
+              </a:rPr>
+              <a:t>• EA Activation + Secure Access PDI + Meraki Deployment + ThousandEyes + CLCs</a:t>
+            </a:r>
+          </a:p>
+          <a:p>
+            <a:pPr>
+              <a:spcBef>
+                <a:spcPts val="200"/>
+              </a:spcBef>
+            </a:pPr>
+            <a:r>
+              <a:rPr sz="1000">
+                <a:solidFill>
+                  <a:srgbClr val="E0E0E0"/>
+                </a:solidFill>
+              </a:rPr>
+              <a:t>• Optional: Talos Incident Response Retainer for distributed manufacturing sites</a:t>
             </a:r>
           </a:p>
         </p:txBody>
@@ -3718,15 +3943,13 @@
           </a:bodyPr>
           <a:lstStyle/>
           <a:p>
-            <a:pPr algn="ctr">
-              <a:defRPr sz="900">
-                <a:solidFill>
-                  <a:srgbClr val="666666"/>
-                </a:solidFill>
-              </a:defRPr>
-            </a:pPr>
-            <a:r>
-              <a:t>Cisco Confidential | Indicative Pricing Only</a:t>
+            <a:r>
+              <a:rPr sz="900" i="1">
+                <a:solidFill>
+                  <a:srgbClr val="999999"/>
+                </a:solidFill>
+              </a:rPr>
+              <a:t>Cisco Confidential | Indicative PS Recommendations — Not a formal quote</a:t>
             </a:r>
           </a:p>
         </p:txBody>
@@ -3742,6 +3965,14 @@
 <file path=ppt/slides/slide11.xml><?xml version="1.0" encoding="utf-8"?>
 <p:sld xmlns:a="http://schemas.openxmlformats.org/drawingml/2006/main" xmlns:p="http://schemas.openxmlformats.org/presentationml/2006/main" xmlns:r="http://schemas.openxmlformats.org/officeDocument/2006/relationships">
   <p:cSld>
+    <p:bg>
+      <p:bgPr>
+        <a:solidFill>
+          <a:srgbClr val="1A2B4A"/>
+        </a:solidFill>
+        <a:effectLst/>
+      </p:bgPr>
+    </p:bg>
     <p:spTree>
       <p:nvGrpSpPr>
         <p:cNvPr id="1" name=""/>
@@ -3822,12 +4053,10 @@
               </a:defRPr>
             </a:pPr>
             <a:r>
-              <a:rPr b="1" sz="2800">
-                <a:solidFill>
-                  <a:srgbClr val="FFFFFF"/>
-                </a:solidFill>
-              </a:rPr>
-              <a:t>Recommended Professional Services</a:t>
+              <a:rPr>
+                <a:solidFill/>
+              </a:rPr>
+              <a:t>Next Steps &amp; Important Notes</a:t>
             </a:r>
           </a:p>
         </p:txBody>
@@ -3858,334 +4087,179 @@
               <a:spcAft>
                 <a:spcPts val="800"/>
               </a:spcAft>
-              <a:defRPr sz="1800">
-                <a:solidFill>
-                  <a:srgbClr val="333333"/>
-                </a:solidFill>
-              </a:defRPr>
-            </a:pPr>
-            <a:r>
-              <a:rPr b="1" sz="1200">
-                <a:solidFill>
-                  <a:srgbClr val="007BC7"/>
-                </a:solidFill>
-              </a:rPr>
-              <a:t>Context</a:t>
-            </a:r>
-          </a:p>
-          <a:p>
-            <a:pPr>
-              <a:spcBef>
-                <a:spcPts val="200"/>
-              </a:spcBef>
-            </a:pPr>
-            <a:r>
-              <a:rPr sz="1000">
-                <a:solidFill>
-                  <a:srgbClr val="333333"/>
-                </a:solidFill>
-              </a:rPr>
-              <a:t>• Professional Services are not included in Proposal 9305711 (~$1.24M support is in scope).</a:t>
-            </a:r>
-          </a:p>
-          <a:p>
-            <a:pPr>
-              <a:spcBef>
-                <a:spcPts val="200"/>
-              </a:spcBef>
-            </a:pPr>
-            <a:r>
-              <a:rPr sz="1000">
-                <a:solidFill>
-                  <a:srgbClr val="333333"/>
-                </a:solidFill>
-              </a:rPr>
-              <a:t>• Recommendations align EA portfolios with Cisco Support / PS lifecycle: Activate → Integrate → Optimize.</a:t>
-            </a:r>
-          </a:p>
-          <a:p>
-            <a:pPr>
-              <a:spcBef>
-                <a:spcPts val="600"/>
-              </a:spcBef>
-            </a:pPr>
-            <a:r>
-              <a:rPr b="1" sz="1200">
-                <a:solidFill>
-                  <a:srgbClr val="007BC7"/>
-                </a:solidFill>
-              </a:rPr>
-              <a:t>Tier 1 — EA Activation (Must-Have)</a:t>
-            </a:r>
-          </a:p>
-          <a:p>
-            <a:pPr>
-              <a:spcBef>
-                <a:spcPts val="200"/>
-              </a:spcBef>
-            </a:pPr>
-            <a:r>
-              <a:rPr sz="1000">
-                <a:solidFill>
-                  <a:srgbClr val="333333"/>
-                </a:solidFill>
-              </a:rPr>
-              <a:t>• Enterprise Agreement Management Support (included with Services EA purchase)</a:t>
-            </a:r>
-          </a:p>
-          <a:p>
-            <a:pPr>
-              <a:spcBef>
-                <a:spcPts val="200"/>
-              </a:spcBef>
-            </a:pPr>
-            <a:r>
-              <a:rPr sz="1000">
-                <a:solidFill>
-                  <a:srgbClr val="333333"/>
-                </a:solidFill>
-              </a:rPr>
-              <a:t>• Install Base Assessment &amp; Entitlement Reconciliation</a:t>
-            </a:r>
-          </a:p>
-          <a:p>
-            <a:pPr>
-              <a:spcBef>
-                <a:spcPts val="200"/>
-              </a:spcBef>
-            </a:pPr>
-            <a:r>
-              <a:rPr sz="1000">
-                <a:solidFill>
-                  <a:srgbClr val="333333"/>
-                </a:solidFill>
-              </a:rPr>
-              <a:t>• EA Activation &amp; License Consumption Planning (pre-EA assets consumed at activation)</a:t>
-            </a:r>
-          </a:p>
-          <a:p>
-            <a:pPr>
-              <a:spcBef>
-                <a:spcPts val="600"/>
-              </a:spcBef>
-            </a:pPr>
-            <a:r>
-              <a:rPr b="1" sz="1200">
-                <a:solidFill>
-                  <a:srgbClr val="007BC7"/>
-                </a:solidFill>
-              </a:rPr>
-              <a:t>Tier 2 — Highest EA Impact</a:t>
-            </a:r>
-          </a:p>
-          <a:p>
-            <a:pPr>
-              <a:spcBef>
-                <a:spcPts val="200"/>
-              </a:spcBef>
-            </a:pPr>
-            <a:r>
-              <a:rPr sz="1000">
-                <a:solidFill>
-                  <a:srgbClr val="333333"/>
-                </a:solidFill>
-              </a:rPr>
-              <a:t>• Secure Access (SASE) Plan, Design &amp; Implement — 3,000 users ($691K SSE software)</a:t>
-            </a:r>
-          </a:p>
-          <a:p>
-            <a:pPr>
-              <a:spcBef>
-                <a:spcPts val="200"/>
-              </a:spcBef>
-            </a:pPr>
-            <a:r>
-              <a:rPr sz="1000">
-                <a:solidFill>
-                  <a:srgbClr val="333333"/>
-                </a:solidFill>
-              </a:rPr>
-              <a:t>• Meraki At-Scale Deployment &amp; Optimization — 609 APs, 150 switches, 56 MX</a:t>
-            </a:r>
-          </a:p>
-          <a:p>
-            <a:pPr>
-              <a:spcBef>
-                <a:spcPts val="200"/>
-              </a:spcBef>
-            </a:pPr>
-            <a:r>
-              <a:rPr sz="1000">
-                <a:solidFill>
-                  <a:srgbClr val="333333"/>
-                </a:solidFill>
-              </a:rPr>
-              <a:t>• Meraki ↔ Secure Access SASE Integration (MX 19.1+, Security Cloud Control)</a:t>
-            </a:r>
-          </a:p>
-          <a:p>
-            <a:pPr>
-              <a:spcBef>
-                <a:spcPts val="200"/>
-              </a:spcBef>
-            </a:pPr>
-            <a:r>
-              <a:rPr sz="1000">
-                <a:solidFill>
-                  <a:srgbClr val="333333"/>
-                </a:solidFill>
-              </a:rPr>
-              <a:t>• Catalyst / Nexus DNA EA Onboarding &amp; Automation</a:t>
-            </a:r>
-          </a:p>
-          <a:p>
-            <a:pPr>
-              <a:spcBef>
-                <a:spcPts val="600"/>
-              </a:spcBef>
-            </a:pPr>
-            <a:r>
-              <a:rPr b="1" sz="1200">
-                <a:solidFill>
-                  <a:srgbClr val="007BC7"/>
-                </a:solidFill>
-              </a:rPr>
-              <a:t>Tier 3 — Security &amp; Observability</a:t>
-            </a:r>
-          </a:p>
-          <a:p>
-            <a:pPr>
-              <a:spcBef>
-                <a:spcPts val="200"/>
-              </a:spcBef>
-            </a:pPr>
-            <a:r>
-              <a:rPr sz="1000">
-                <a:solidFill>
-                  <a:srgbClr val="333333"/>
-                </a:solidFill>
-              </a:rPr>
-              <a:t>• Duo + ISE Zero Trust PDI (2,500 / 8,000) | Secure Firewall FTD PDI (45 devices)</a:t>
-            </a:r>
-          </a:p>
-          <a:p>
-            <a:pPr>
-              <a:spcBef>
-                <a:spcPts val="200"/>
-              </a:spcBef>
-            </a:pPr>
-            <a:r>
-              <a:rPr sz="1000">
-                <a:solidFill>
-                  <a:srgbClr val="333333"/>
-                </a:solidFill>
-              </a:rPr>
-              <a:t>• ThousandEyes Deployment — 4,000 agents (+1,500 net new)</a:t>
-            </a:r>
-          </a:p>
-          <a:p>
-            <a:pPr>
-              <a:spcBef>
-                <a:spcPts val="200"/>
-              </a:spcBef>
-            </a:pPr>
-            <a:r>
-              <a:rPr sz="1000">
-                <a:solidFill>
-                  <a:srgbClr val="333333"/>
-                </a:solidFill>
-              </a:rPr>
-              <a:t>• SD-WAN / ENTWAN Plan, Design &amp; Implement</a:t>
-            </a:r>
-          </a:p>
-          <a:p>
-            <a:pPr>
-              <a:spcBef>
-                <a:spcPts val="600"/>
-              </a:spcBef>
-            </a:pPr>
-            <a:r>
-              <a:rPr b="1" sz="1200">
-                <a:solidFill>
-                  <a:srgbClr val="007BC7"/>
-                </a:solidFill>
-              </a:rPr>
-              <a:t>Support &amp; Enablement (Customer Value Framework)</a:t>
-            </a:r>
-          </a:p>
-          <a:p>
-            <a:pPr>
-              <a:spcBef>
-                <a:spcPts val="200"/>
-              </a:spcBef>
-            </a:pPr>
-            <a:r>
-              <a:rPr sz="1000">
-                <a:solidFill>
-                  <a:srgbClr val="333333"/>
-                </a:solidFill>
-              </a:rPr>
-              <a:t>• Add Services EA wrapper for unified renewal | Signature Support for critical campus/DC</a:t>
-            </a:r>
-          </a:p>
-          <a:p>
-            <a:pPr>
-              <a:spcBef>
-                <a:spcPts val="200"/>
-              </a:spcBef>
-            </a:pPr>
-            <a:r>
-              <a:rPr sz="1000">
-                <a:solidFill>
-                  <a:srgbClr val="333333"/>
-                </a:solidFill>
-              </a:rPr>
-              <a:t>• Standard Support for Secure Access, Duo, ISE, ThousandEyes | Cisco Learning Credits for ops teams</a:t>
-            </a:r>
-          </a:p>
-          <a:p>
-            <a:pPr>
-              <a:spcBef>
-                <a:spcPts val="600"/>
-              </a:spcBef>
-            </a:pPr>
-            <a:r>
-              <a:rPr b="1" sz="1200">
-                <a:solidFill>
-                  <a:srgbClr val="007BC7"/>
-                </a:solidFill>
-              </a:rPr>
-              <a:t>Suggested Starter Bundle</a:t>
-            </a:r>
-          </a:p>
-          <a:p>
-            <a:pPr>
-              <a:spcBef>
-                <a:spcPts val="200"/>
-              </a:spcBef>
-            </a:pPr>
-            <a:r>
-              <a:rPr sz="1000">
-                <a:solidFill>
-                  <a:srgbClr val="333333"/>
-                </a:solidFill>
-              </a:rPr>
-              <a:t>• EA Activation + Secure Access PDI + Meraki Deployment + ThousandEyes + CLCs</a:t>
-            </a:r>
-          </a:p>
-          <a:p>
-            <a:pPr>
-              <a:spcBef>
-                <a:spcPts val="200"/>
-              </a:spcBef>
-            </a:pPr>
-            <a:r>
-              <a:rPr sz="1000">
-                <a:solidFill>
-                  <a:srgbClr val="333333"/>
-                </a:solidFill>
-              </a:rPr>
-              <a:t>• Optional: Talos Incident Response Retainer for distributed manufacturing sites</a:t>
+              <a:defRPr sz="1500">
+                <a:solidFill>
+                  <a:srgbClr val="E0E0E0"/>
+                </a:solidFill>
+              </a:defRPr>
+            </a:pPr>
+            <a:r>
+              <a:rPr>
+                <a:solidFill/>
+              </a:rPr>
+              <a:t>Important Disclaimers</a:t>
+            </a:r>
+          </a:p>
+          <a:p>
+            <a:pPr>
+              <a:spcAft>
+                <a:spcPts val="800"/>
+              </a:spcAft>
+              <a:defRPr sz="1500">
+                <a:solidFill>
+                  <a:srgbClr val="E0E0E0"/>
+                </a:solidFill>
+              </a:defRPr>
+            </a:pPr>
+            <a:r>
+              <a:rPr>
+                <a:solidFill/>
+              </a:rPr>
+              <a:t>This is indicative pricing only — NOT an approved Cisco quote</a:t>
+            </a:r>
+          </a:p>
+          <a:p>
+            <a:pPr>
+              <a:spcAft>
+                <a:spcPts val="800"/>
+              </a:spcAft>
+              <a:defRPr sz="1500">
+                <a:solidFill>
+                  <a:srgbClr val="E0E0E0"/>
+                </a:solidFill>
+              </a:defRPr>
+            </a:pPr>
+            <a:r>
+              <a:rPr>
+                <a:solidFill/>
+              </a:rPr>
+              <a:t>Pricing is subject to change until formal quote approval</a:t>
+            </a:r>
+          </a:p>
+          <a:p>
+            <a:pPr>
+              <a:spcAft>
+                <a:spcPts val="800"/>
+              </a:spcAft>
+              <a:defRPr sz="1500">
+                <a:solidFill>
+                  <a:srgbClr val="E0E0E0"/>
+                </a:solidFill>
+              </a:defRPr>
+            </a:pPr>
+            <a:r>
+              <a:rPr>
+                <a:solidFill/>
+              </a:rPr>
+              <a:t>Pre-EA install base licenses will be consumed at EA activation</a:t>
+            </a:r>
+          </a:p>
+          <a:p>
+            <a:pPr>
+              <a:spcAft>
+                <a:spcPts val="800"/>
+              </a:spcAft>
+              <a:defRPr sz="1500">
+                <a:solidFill>
+                  <a:srgbClr val="E0E0E0"/>
+                </a:solidFill>
+              </a:defRPr>
+            </a:pPr>
+            <a:r>
+              <a:rPr>
+                <a:solidFill/>
+              </a:rPr>
+              <a:t>Recommended Actions</a:t>
+            </a:r>
+          </a:p>
+          <a:p>
+            <a:pPr>
+              <a:spcAft>
+                <a:spcPts val="800"/>
+              </a:spcAft>
+              <a:defRPr sz="1500">
+                <a:solidFill>
+                  <a:srgbClr val="E0E0E0"/>
+                </a:solidFill>
+              </a:defRPr>
+            </a:pPr>
+            <a:r>
+              <a:rPr>
+                <a:solidFill/>
+              </a:rPr>
+              <a:t>Review portfolio quantities against current install base</a:t>
+            </a:r>
+          </a:p>
+          <a:p>
+            <a:pPr>
+              <a:spcAft>
+                <a:spcPts val="800"/>
+              </a:spcAft>
+              <a:defRPr sz="1500">
+                <a:solidFill>
+                  <a:srgbClr val="E0E0E0"/>
+                </a:solidFill>
+              </a:defRPr>
+            </a:pPr>
+            <a:r>
+              <a:rPr>
+                <a:solidFill/>
+              </a:rPr>
+              <a:t>Validate Meraki (609 APs) and Secure Access (3,000 user) counts</a:t>
+            </a:r>
+          </a:p>
+          <a:p>
+            <a:pPr>
+              <a:spcAft>
+                <a:spcPts val="800"/>
+              </a:spcAft>
+              <a:defRPr sz="1500">
+                <a:solidFill>
+                  <a:srgbClr val="E0E0E0"/>
+                </a:solidFill>
+              </a:defRPr>
+            </a:pPr>
+            <a:r>
+              <a:rPr>
+                <a:solidFill/>
+              </a:rPr>
+              <a:t>Confirm support coverage levels (8x5xNBD vs 24x7x4) meet SLA requirements</a:t>
+            </a:r>
+          </a:p>
+          <a:p>
+            <a:pPr>
+              <a:spcAft>
+                <a:spcPts val="800"/>
+              </a:spcAft>
+              <a:defRPr sz="1500">
+                <a:solidFill>
+                  <a:srgbClr val="E0E0E0"/>
+                </a:solidFill>
+              </a:defRPr>
+            </a:pPr>
+            <a:r>
+              <a:rPr>
+                <a:solidFill/>
+              </a:rPr>
+              <a:t>Work with CDW and Cisco AM Robin Randolph to finalize quote</a:t>
+            </a:r>
+          </a:p>
+          <a:p>
+            <a:pPr>
+              <a:spcAft>
+                <a:spcPts val="800"/>
+              </a:spcAft>
+              <a:defRPr sz="1500">
+                <a:solidFill>
+                  <a:srgbClr val="E0E0E0"/>
+                </a:solidFill>
+              </a:defRPr>
+            </a:pPr>
+            <a:r>
+              <a:rPr>
+                <a:solidFill/>
+              </a:rPr>
+              <a:t>EA Proposal Link: apps.cisco.com/ea/project/proposal/9305711</a:t>
             </a:r>
           </a:p>
         </p:txBody>
@@ -4212,13 +4286,18 @@
           </a:bodyPr>
           <a:lstStyle/>
           <a:p>
-            <a:r>
-              <a:rPr sz="900" i="1">
-                <a:solidFill>
-                  <a:srgbClr val="666666"/>
-                </a:solidFill>
-              </a:rPr>
-              <a:t>Cisco Confidential | Indicative PS Recommendations — Not a formal quote</a:t>
+            <a:pPr algn="ctr">
+              <a:defRPr sz="900">
+                <a:solidFill>
+                  <a:srgbClr val="999999"/>
+                </a:solidFill>
+              </a:defRPr>
+            </a:pPr>
+            <a:r>
+              <a:rPr>
+                <a:solidFill/>
+              </a:rPr>
+              <a:t>Cisco Confidential | Indicative Pricing Only</a:t>
             </a:r>
           </a:p>
         </p:txBody>
@@ -4234,6 +4313,14 @@
 <file path=ppt/slides/slide2.xml><?xml version="1.0" encoding="utf-8"?>
 <p:sld xmlns:a="http://schemas.openxmlformats.org/drawingml/2006/main" xmlns:p="http://schemas.openxmlformats.org/presentationml/2006/main" xmlns:r="http://schemas.openxmlformats.org/officeDocument/2006/relationships">
   <p:cSld>
+    <p:bg>
+      <p:bgPr>
+        <a:solidFill>
+          <a:srgbClr val="1A2B4A"/>
+        </a:solidFill>
+        <a:effectLst/>
+      </p:bgPr>
+    </p:bg>
     <p:spTree>
       <p:nvGrpSpPr>
         <p:cNvPr id="1" name=""/>
@@ -4314,6 +4401,9 @@
               </a:defRPr>
             </a:pPr>
             <a:r>
+              <a:rPr>
+                <a:solidFill/>
+              </a:rPr>
               <a:t>Deal Overview</a:t>
             </a:r>
           </a:p>
@@ -4347,11 +4437,14 @@
               </a:spcAft>
               <a:defRPr sz="1600">
                 <a:solidFill>
-                  <a:srgbClr val="333333"/>
-                </a:solidFill>
-              </a:defRPr>
-            </a:pPr>
-            <a:r>
+                  <a:srgbClr val="E0E0E0"/>
+                </a:solidFill>
+              </a:defRPr>
+            </a:pPr>
+            <a:r>
+              <a:rPr>
+                <a:solidFill/>
+              </a:rPr>
               <a:t>Customer &amp; Partners</a:t>
             </a:r>
           </a:p>
@@ -4362,11 +4455,14 @@
               </a:spcAft>
               <a:defRPr sz="1600">
                 <a:solidFill>
-                  <a:srgbClr val="333333"/>
-                </a:solidFill>
-              </a:defRPr>
-            </a:pPr>
-            <a:r>
+                  <a:srgbClr val="E0E0E0"/>
+                </a:solidFill>
+              </a:defRPr>
+            </a:pPr>
+            <a:r>
+              <a:rPr>
+                <a:solidFill/>
+              </a:rPr>
               <a:t>End Customer: Seaboard Corporation US (Smart Account: SEABOARD FOODS)</a:t>
             </a:r>
           </a:p>
@@ -4377,11 +4473,14 @@
               </a:spcAft>
               <a:defRPr sz="1600">
                 <a:solidFill>
-                  <a:srgbClr val="333333"/>
-                </a:solidFill>
-              </a:defRPr>
-            </a:pPr>
-            <a:r>
+                  <a:srgbClr val="E0E0E0"/>
+                </a:solidFill>
+              </a:defRPr>
+            </a:pPr>
+            <a:r>
+              <a:rPr>
+                <a:solidFill/>
+              </a:rPr>
               <a:t>Address: 9000 W 67th St, Ste 200, Mission, KS 66202</a:t>
             </a:r>
           </a:p>
@@ -4392,11 +4491,14 @@
               </a:spcAft>
               <a:defRPr sz="1600">
                 <a:solidFill>
-                  <a:srgbClr val="333333"/>
-                </a:solidFill>
-              </a:defRPr>
-            </a:pPr>
-            <a:r>
+                  <a:srgbClr val="E0E0E0"/>
+                </a:solidFill>
+              </a:defRPr>
+            </a:pPr>
+            <a:r>
+              <a:rPr>
+                <a:solidFill/>
+              </a:rPr>
               <a:t>Partner: CDW</a:t>
             </a:r>
           </a:p>
@@ -4407,11 +4509,14 @@
               </a:spcAft>
               <a:defRPr sz="1600">
                 <a:solidFill>
-                  <a:srgbClr val="333333"/>
-                </a:solidFill>
-              </a:defRPr>
-            </a:pPr>
-            <a:r>
+                  <a:srgbClr val="E0E0E0"/>
+                </a:solidFill>
+              </a:defRPr>
+            </a:pPr>
+            <a:r>
+              <a:rPr>
+                <a:solidFill/>
+              </a:rPr>
               <a:t>Reseller Services: Sirius Computer Solutions LLC</a:t>
             </a:r>
           </a:p>
@@ -4422,11 +4527,14 @@
               </a:spcAft>
               <a:defRPr sz="1600">
                 <a:solidFill>
-                  <a:srgbClr val="333333"/>
-                </a:solidFill>
-              </a:defRPr>
-            </a:pPr>
-            <a:r>
+                  <a:srgbClr val="E0E0E0"/>
+                </a:solidFill>
+              </a:defRPr>
+            </a:pPr>
+            <a:r>
+              <a:rPr>
+                <a:solidFill/>
+              </a:rPr>
               <a:t>Cisco Account Manager: Robin Randolph (robrando@cisco.com)</a:t>
             </a:r>
           </a:p>
@@ -4437,11 +4545,14 @@
               </a:spcAft>
               <a:defRPr sz="1600">
                 <a:solidFill>
-                  <a:srgbClr val="333333"/>
-                </a:solidFill>
-              </a:defRPr>
-            </a:pPr>
-            <a:r>
+                  <a:srgbClr val="E0E0E0"/>
+                </a:solidFill>
+              </a:defRPr>
+            </a:pPr>
+            <a:r>
+              <a:rPr>
+                <a:solidFill/>
+              </a:rPr>
               <a:t>Agreement Details</a:t>
             </a:r>
           </a:p>
@@ -4452,11 +4563,14 @@
               </a:spcAft>
               <a:defRPr sz="1600">
                 <a:solidFill>
-                  <a:srgbClr val="333333"/>
-                </a:solidFill>
-              </a:defRPr>
-            </a:pPr>
-            <a:r>
+                  <a:srgbClr val="E0E0E0"/>
+                </a:solidFill>
+              </a:defRPr>
+            </a:pPr>
+            <a:r>
+              <a:rPr>
+                <a:solidFill/>
+              </a:rPr>
               <a:t>Enterprise Agreement Motion: EA 3.0</a:t>
             </a:r>
           </a:p>
@@ -4467,11 +4581,14 @@
               </a:spcAft>
               <a:defRPr sz="1600">
                 <a:solidFill>
-                  <a:srgbClr val="333333"/>
-                </a:solidFill>
-              </a:defRPr>
-            </a:pPr>
-            <a:r>
+                  <a:srgbClr val="E0E0E0"/>
+                </a:solidFill>
+              </a:defRPr>
+            </a:pPr>
+            <a:r>
+              <a:rPr>
+                <a:solidFill/>
+              </a:rPr>
               <a:t>Buying Program ID: EA83160</a:t>
             </a:r>
           </a:p>
@@ -4482,11 +4599,14 @@
               </a:spcAft>
               <a:defRPr sz="1600">
                 <a:solidFill>
-                  <a:srgbClr val="333333"/>
-                </a:solidFill>
-              </a:defRPr>
-            </a:pPr>
-            <a:r>
+                  <a:srgbClr val="E0E0E0"/>
+                </a:solidFill>
+              </a:defRPr>
+            </a:pPr>
+            <a:r>
+              <a:rPr>
+                <a:solidFill/>
+              </a:rPr>
               <a:t>Deal ID: 84632415  |  Quote ID: 4795356749</a:t>
             </a:r>
           </a:p>
@@ -4497,11 +4617,14 @@
               </a:spcAft>
               <a:defRPr sz="1600">
                 <a:solidFill>
-                  <a:srgbClr val="333333"/>
-                </a:solidFill>
-              </a:defRPr>
-            </a:pPr>
-            <a:r>
+                  <a:srgbClr val="E0E0E0"/>
+                </a:solidFill>
+              </a:defRPr>
+            </a:pPr>
+            <a:r>
+              <a:rPr>
+                <a:solidFill/>
+              </a:rPr>
               <a:t>Price List: Global Price List US Availability</a:t>
             </a:r>
           </a:p>
@@ -4512,11 +4635,14 @@
               </a:spcAft>
               <a:defRPr sz="1600">
                 <a:solidFill>
-                  <a:srgbClr val="333333"/>
-                </a:solidFill>
-              </a:defRPr>
-            </a:pPr>
-            <a:r>
+                  <a:srgbClr val="E0E0E0"/>
+                </a:solidFill>
+              </a:defRPr>
+            </a:pPr>
+            <a:r>
+              <a:rPr>
+                <a:solidFill/>
+              </a:rPr>
               <a:t>Duration: 36 months  |  Billing: Annual  |  RSD: August 4, 2026</a:t>
             </a:r>
           </a:p>
@@ -4533,6 +4659,14 @@
 <file path=ppt/slides/slide3.xml><?xml version="1.0" encoding="utf-8"?>
 <p:sld xmlns:a="http://schemas.openxmlformats.org/drawingml/2006/main" xmlns:p="http://schemas.openxmlformats.org/presentationml/2006/main" xmlns:r="http://schemas.openxmlformats.org/officeDocument/2006/relationships">
   <p:cSld>
+    <p:bg>
+      <p:bgPr>
+        <a:solidFill>
+          <a:srgbClr val="1A2B4A"/>
+        </a:solidFill>
+        <a:effectLst/>
+      </p:bgPr>
+    </p:bg>
     <p:spTree>
       <p:nvGrpSpPr>
         <p:cNvPr id="1" name=""/>
@@ -4613,6 +4747,9 @@
               </a:defRPr>
             </a:pPr>
             <a:r>
+              <a:rPr>
+                <a:solidFill/>
+              </a:rPr>
               <a:t>Executive Summary</a:t>
             </a:r>
           </a:p>
@@ -4643,11 +4780,14 @@
             <a:pPr>
               <a:defRPr sz="1400">
                 <a:solidFill>
-                  <a:srgbClr val="CCE8F7"/>
-                </a:solidFill>
-              </a:defRPr>
-            </a:pPr>
-            <a:r>
+                  <a:srgbClr val="243B5C"/>
+                </a:solidFill>
+              </a:defRPr>
+            </a:pPr>
+            <a:r>
+              <a:rPr>
+                <a:solidFill/>
+              </a:rPr>
               <a:t>3-Year Total Contract Value: $3,005,142.52</a:t>
             </a:r>
           </a:p>
@@ -4691,6 +4831,9 @@
                         </a:defRPr>
                       </a:pPr>
                       <a:r>
+                        <a:rPr>
+                          <a:solidFill/>
+                        </a:rPr>
                         <a:t>Portfolio</a:t>
                       </a:r>
                     </a:p>
@@ -4714,6 +4857,9 @@
                         </a:defRPr>
                       </a:pPr>
                       <a:r>
+                        <a:rPr>
+                          <a:solidFill/>
+                        </a:rPr>
                         <a:t>Software (USD)</a:t>
                       </a:r>
                     </a:p>
@@ -4737,6 +4883,9 @@
                         </a:defRPr>
                       </a:pPr>
                       <a:r>
+                        <a:rPr>
+                          <a:solidFill/>
+                        </a:rPr>
                         <a:t>Services (USD)</a:t>
                       </a:r>
                     </a:p>
@@ -4760,6 +4909,9 @@
                         </a:defRPr>
                       </a:pPr>
                       <a:r>
+                        <a:rPr>
+                          <a:solidFill/>
+                        </a:rPr>
                         <a:t>Total (USD)</a:t>
                       </a:r>
                     </a:p>
@@ -4781,13 +4933,16 @@
                         <a:defRPr sz="1100"/>
                       </a:pPr>
                       <a:r>
+                        <a:rPr>
+                          <a:solidFill/>
+                        </a:rPr>
                         <a:t>Networking Infrastructure</a:t>
                       </a:r>
                     </a:p>
                   </a:txBody>
                   <a:tcPr>
                     <a:solidFill>
-                      <a:srgbClr val="F5F5F5"/>
+                      <a:srgbClr val="2D3A52"/>
                     </a:solidFill>
                   </a:tcPr>
                 </a:tc>
@@ -4800,13 +4955,16 @@
                         <a:defRPr sz="1100"/>
                       </a:pPr>
                       <a:r>
+                        <a:rPr>
+                          <a:solidFill/>
+                        </a:rPr>
                         <a:t>$639,764</a:t>
                       </a:r>
                     </a:p>
                   </a:txBody>
                   <a:tcPr>
                     <a:solidFill>
-                      <a:srgbClr val="F5F5F5"/>
+                      <a:srgbClr val="2D3A52"/>
                     </a:solidFill>
                   </a:tcPr>
                 </a:tc>
@@ -4819,13 +4977,16 @@
                         <a:defRPr sz="1100"/>
                       </a:pPr>
                       <a:r>
+                        <a:rPr>
+                          <a:solidFill/>
+                        </a:rPr>
                         <a:t>—</a:t>
                       </a:r>
                     </a:p>
                   </a:txBody>
                   <a:tcPr>
                     <a:solidFill>
-                      <a:srgbClr val="F5F5F5"/>
+                      <a:srgbClr val="2D3A52"/>
                     </a:solidFill>
                   </a:tcPr>
                 </a:tc>
@@ -4838,13 +4999,16 @@
                         <a:defRPr sz="1100"/>
                       </a:pPr>
                       <a:r>
+                        <a:rPr>
+                          <a:solidFill/>
+                        </a:rPr>
                         <a:t>$639,764</a:t>
                       </a:r>
                     </a:p>
                   </a:txBody>
                   <a:tcPr>
                     <a:solidFill>
-                      <a:srgbClr val="F5F5F5"/>
+                      <a:srgbClr val="2D3A52"/>
                     </a:solidFill>
                   </a:tcPr>
                 </a:tc>
@@ -4859,6 +5023,9 @@
                         <a:defRPr sz="1100"/>
                       </a:pPr>
                       <a:r>
+                        <a:rPr>
+                          <a:solidFill/>
+                        </a:rPr>
                         <a:t>Applications Infrastructure</a:t>
                       </a:r>
                     </a:p>
@@ -4874,6 +5041,9 @@
                         <a:defRPr sz="1100"/>
                       </a:pPr>
                       <a:r>
+                        <a:rPr>
+                          <a:solidFill/>
+                        </a:rPr>
                         <a:t>$69,258</a:t>
                       </a:r>
                     </a:p>
@@ -4889,6 +5059,9 @@
                         <a:defRPr sz="1100"/>
                       </a:pPr>
                       <a:r>
+                        <a:rPr>
+                          <a:solidFill/>
+                        </a:rPr>
                         <a:t>—</a:t>
                       </a:r>
                     </a:p>
@@ -4904,6 +5077,9 @@
                         <a:defRPr sz="1100"/>
                       </a:pPr>
                       <a:r>
+                        <a:rPr>
+                          <a:solidFill/>
+                        </a:rPr>
                         <a:t>$69,258</a:t>
                       </a:r>
                     </a:p>
@@ -4921,13 +5097,16 @@
                         <a:defRPr sz="1100"/>
                       </a:pPr>
                       <a:r>
+                        <a:rPr>
+                          <a:solidFill/>
+                        </a:rPr>
                         <a:t>Security</a:t>
                       </a:r>
                     </a:p>
                   </a:txBody>
                   <a:tcPr>
                     <a:solidFill>
-                      <a:srgbClr val="F5F5F5"/>
+                      <a:srgbClr val="2D3A52"/>
                     </a:solidFill>
                   </a:tcPr>
                 </a:tc>
@@ -4940,13 +5119,16 @@
                         <a:defRPr sz="1100"/>
                       </a:pPr>
                       <a:r>
+                        <a:rPr>
+                          <a:solidFill/>
+                        </a:rPr>
                         <a:t>$1,055,037</a:t>
                       </a:r>
                     </a:p>
                   </a:txBody>
                   <a:tcPr>
                     <a:solidFill>
-                      <a:srgbClr val="F5F5F5"/>
+                      <a:srgbClr val="2D3A52"/>
                     </a:solidFill>
                   </a:tcPr>
                 </a:tc>
@@ -4959,13 +5141,16 @@
                         <a:defRPr sz="1100"/>
                       </a:pPr>
                       <a:r>
+                        <a:rPr>
+                          <a:solidFill/>
+                        </a:rPr>
                         <a:t>—</a:t>
                       </a:r>
                     </a:p>
                   </a:txBody>
                   <a:tcPr>
                     <a:solidFill>
-                      <a:srgbClr val="F5F5F5"/>
+                      <a:srgbClr val="2D3A52"/>
                     </a:solidFill>
                   </a:tcPr>
                 </a:tc>
@@ -4978,13 +5163,16 @@
                         <a:defRPr sz="1100"/>
                       </a:pPr>
                       <a:r>
+                        <a:rPr>
+                          <a:solidFill/>
+                        </a:rPr>
                         <a:t>$1,055,037</a:t>
                       </a:r>
                     </a:p>
                   </a:txBody>
                   <a:tcPr>
                     <a:solidFill>
-                      <a:srgbClr val="F5F5F5"/>
+                      <a:srgbClr val="2D3A52"/>
                     </a:solidFill>
                   </a:tcPr>
                 </a:tc>
@@ -4999,6 +5187,9 @@
                         <a:defRPr sz="1100"/>
                       </a:pPr>
                       <a:r>
+                        <a:rPr>
+                          <a:solidFill/>
+                        </a:rPr>
                         <a:t>Support &amp; Lifecycle Services</a:t>
                       </a:r>
                     </a:p>
@@ -5014,6 +5205,9 @@
                         <a:defRPr sz="1100"/>
                       </a:pPr>
                       <a:r>
+                        <a:rPr>
+                          <a:solidFill/>
+                        </a:rPr>
                         <a:t>—</a:t>
                       </a:r>
                     </a:p>
@@ -5029,6 +5223,9 @@
                         <a:defRPr sz="1100"/>
                       </a:pPr>
                       <a:r>
+                        <a:rPr>
+                          <a:solidFill/>
+                        </a:rPr>
                         <a:t>$1,241,084</a:t>
                       </a:r>
                     </a:p>
@@ -5044,6 +5241,9 @@
                         <a:defRPr sz="1100"/>
                       </a:pPr>
                       <a:r>
+                        <a:rPr>
+                          <a:solidFill/>
+                        </a:rPr>
                         <a:t>$1,241,084</a:t>
                       </a:r>
                     </a:p>
@@ -5061,13 +5261,16 @@
                         <a:defRPr sz="1100"/>
                       </a:pPr>
                       <a:r>
+                        <a:rPr>
+                          <a:solidFill/>
+                        </a:rPr>
                         <a:t>TOTAL</a:t>
                       </a:r>
                     </a:p>
                   </a:txBody>
                   <a:tcPr>
                     <a:solidFill>
-                      <a:srgbClr val="F5F5F5"/>
+                      <a:srgbClr val="2D3A52"/>
                     </a:solidFill>
                   </a:tcPr>
                 </a:tc>
@@ -5080,13 +5283,16 @@
                         <a:defRPr sz="1100"/>
                       </a:pPr>
                       <a:r>
+                        <a:rPr>
+                          <a:solidFill/>
+                        </a:rPr>
                         <a:t>$1,764,058</a:t>
                       </a:r>
                     </a:p>
                   </a:txBody>
                   <a:tcPr>
                     <a:solidFill>
-                      <a:srgbClr val="F5F5F5"/>
+                      <a:srgbClr val="2D3A52"/>
                     </a:solidFill>
                   </a:tcPr>
                 </a:tc>
@@ -5099,13 +5305,16 @@
                         <a:defRPr sz="1100"/>
                       </a:pPr>
                       <a:r>
+                        <a:rPr>
+                          <a:solidFill/>
+                        </a:rPr>
                         <a:t>$1,241,084</a:t>
                       </a:r>
                     </a:p>
                   </a:txBody>
                   <a:tcPr>
                     <a:solidFill>
-                      <a:srgbClr val="F5F5F5"/>
+                      <a:srgbClr val="2D3A52"/>
                     </a:solidFill>
                   </a:tcPr>
                 </a:tc>
@@ -5118,13 +5327,16 @@
                         <a:defRPr sz="1100"/>
                       </a:pPr>
                       <a:r>
+                        <a:rPr>
+                          <a:solidFill/>
+                        </a:rPr>
                         <a:t>$3,005,143</a:t>
                       </a:r>
                     </a:p>
                   </a:txBody>
                   <a:tcPr>
                     <a:solidFill>
-                      <a:srgbClr val="F5F5F5"/>
+                      <a:srgbClr val="2D3A52"/>
                     </a:solidFill>
                   </a:tcPr>
                 </a:tc>
@@ -5181,6 +5393,9 @@
               </a:defRPr>
             </a:pPr>
             <a:r>
+              <a:rPr>
+                <a:solidFill/>
+              </a:rPr>
               <a:t>Key Highlights</a:t>
             </a:r>
           </a:p>
@@ -5188,11 +5403,14 @@
             <a:pPr>
               <a:defRPr sz="1300">
                 <a:solidFill>
-                  <a:srgbClr val="333333"/>
-                </a:solidFill>
-              </a:defRPr>
-            </a:pPr>
-            <a:r>
+                  <a:srgbClr val="E0E0E0"/>
+                </a:solidFill>
+              </a:defRPr>
+            </a:pPr>
+            <a:r>
+              <a:rPr>
+                <a:solidFill/>
+              </a:rPr>
               <a:t>• Security is the largest portfolio at 35% of total TCV</a:t>
             </a:r>
           </a:p>
@@ -5200,11 +5418,14 @@
             <a:pPr>
               <a:defRPr sz="1300">
                 <a:solidFill>
-                  <a:srgbClr val="333333"/>
-                </a:solidFill>
-              </a:defRPr>
-            </a:pPr>
-            <a:r>
+                  <a:srgbClr val="E0E0E0"/>
+                </a:solidFill>
+              </a:defRPr>
+            </a:pPr>
+            <a:r>
+              <a:rPr>
+                <a:solidFill/>
+              </a:rPr>
               <a:t>• Meraki + Catalyst/Nexus networking modernization</a:t>
             </a:r>
           </a:p>
@@ -5212,11 +5433,14 @@
             <a:pPr>
               <a:defRPr sz="1300">
                 <a:solidFill>
-                  <a:srgbClr val="333333"/>
-                </a:solidFill>
-              </a:defRPr>
-            </a:pPr>
-            <a:r>
+                  <a:srgbClr val="E0E0E0"/>
+                </a:solidFill>
+              </a:defRPr>
+            </a:pPr>
+            <a:r>
+              <a:rPr>
+                <a:solidFill/>
+              </a:rPr>
               <a:t>• Cisco Secure Access (SSE) for 3,000 users</a:t>
             </a:r>
           </a:p>
@@ -5224,11 +5448,14 @@
             <a:pPr>
               <a:defRPr sz="1300">
                 <a:solidFill>
-                  <a:srgbClr val="333333"/>
-                </a:solidFill>
-              </a:defRPr>
-            </a:pPr>
-            <a:r>
+                  <a:srgbClr val="E0E0E0"/>
+                </a:solidFill>
+              </a:defRPr>
+            </a:pPr>
+            <a:r>
+              <a:rPr>
+                <a:solidFill/>
+              </a:rPr>
               <a:t>• ThousandEyes observability for 4,000 agents</a:t>
             </a:r>
           </a:p>
@@ -5236,11 +5463,14 @@
             <a:pPr>
               <a:defRPr sz="1300">
                 <a:solidFill>
-                  <a:srgbClr val="333333"/>
-                </a:solidFill>
-              </a:defRPr>
-            </a:pPr>
-            <a:r>
+                  <a:srgbClr val="E0E0E0"/>
+                </a:solidFill>
+              </a:defRPr>
+            </a:pPr>
+            <a:r>
+              <a:rPr>
+                <a:solidFill/>
+              </a:rPr>
               <a:t>• Comprehensive support across switching, WAN, and security</a:t>
             </a:r>
           </a:p>
@@ -5257,6 +5487,14 @@
 <file path=ppt/slides/slide4.xml><?xml version="1.0" encoding="utf-8"?>
 <p:sld xmlns:a="http://schemas.openxmlformats.org/drawingml/2006/main" xmlns:p="http://schemas.openxmlformats.org/presentationml/2006/main" xmlns:r="http://schemas.openxmlformats.org/officeDocument/2006/relationships">
   <p:cSld>
+    <p:bg>
+      <p:bgPr>
+        <a:solidFill>
+          <a:srgbClr val="1A2B4A"/>
+        </a:solidFill>
+        <a:effectLst/>
+      </p:bgPr>
+    </p:bg>
     <p:spTree>
       <p:nvGrpSpPr>
         <p:cNvPr id="1" name=""/>
@@ -5337,6 +5575,9 @@
               </a:defRPr>
             </a:pPr>
             <a:r>
+              <a:rPr>
+                <a:solidFill/>
+              </a:rPr>
               <a:t>Networking Infrastructure</a:t>
             </a:r>
           </a:p>
@@ -5367,11 +5608,14 @@
             <a:pPr>
               <a:defRPr sz="1400">
                 <a:solidFill>
-                  <a:srgbClr val="CCE8F7"/>
-                </a:solidFill>
-              </a:defRPr>
-            </a:pPr>
-            <a:r>
+                  <a:srgbClr val="243B5C"/>
+                </a:solidFill>
+              </a:defRPr>
+            </a:pPr>
+            <a:r>
+              <a:rPr>
+                <a:solidFill/>
+              </a:rPr>
               <a:t>Software TCV: $639,764  |  Services TCV: $955,879</a:t>
             </a:r>
           </a:p>
@@ -5405,11 +5649,14 @@
               </a:spcAft>
               <a:defRPr sz="1500">
                 <a:solidFill>
-                  <a:srgbClr val="333333"/>
-                </a:solidFill>
-              </a:defRPr>
-            </a:pPr>
-            <a:r>
+                  <a:srgbClr val="E0E0E0"/>
+                </a:solidFill>
+              </a:defRPr>
+            </a:pPr>
+            <a:r>
+              <a:rPr>
+                <a:solidFill/>
+              </a:rPr>
               <a:t>Meraki Cloud-Managed (~$251K software)</a:t>
             </a:r>
           </a:p>
@@ -5420,11 +5667,14 @@
               </a:spcAft>
               <a:defRPr sz="1500">
                 <a:solidFill>
-                  <a:srgbClr val="333333"/>
-                </a:solidFill>
-              </a:defRPr>
-            </a:pPr>
-            <a:r>
+                  <a:srgbClr val="E0E0E0"/>
+                </a:solidFill>
+              </a:defRPr>
+            </a:pPr>
+            <a:r>
+              <a:rPr>
+                <a:solidFill/>
+              </a:rPr>
               <a:t>609 × MR Essentials (wireless access points)</a:t>
             </a:r>
           </a:p>
@@ -5435,11 +5685,14 @@
               </a:spcAft>
               <a:defRPr sz="1500">
                 <a:solidFill>
-                  <a:srgbClr val="333333"/>
-                </a:solidFill>
-              </a:defRPr>
-            </a:pPr>
-            <a:r>
+                  <a:srgbClr val="E0E0E0"/>
+                </a:solidFill>
+              </a:defRPr>
+            </a:pPr>
+            <a:r>
+              <a:rPr>
+                <a:solidFill/>
+              </a:rPr>
               <a:t>57 × MS300 Large, 31 × MS200 Medium, 62 × MS100 Medium switches</a:t>
             </a:r>
           </a:p>
@@ -5450,11 +5703,14 @@
               </a:spcAft>
               <a:defRPr sz="1500">
                 <a:solidFill>
-                  <a:srgbClr val="333333"/>
-                </a:solidFill>
-              </a:defRPr>
-            </a:pPr>
-            <a:r>
+                  <a:srgbClr val="E0E0E0"/>
+                </a:solidFill>
+              </a:defRPr>
+            </a:pPr>
+            <a:r>
+              <a:rPr>
+                <a:solidFill/>
+              </a:rPr>
               <a:t>51 × MX Small, 5 × MX Large firewalls/security appliances</a:t>
             </a:r>
           </a:p>
@@ -5465,11 +5721,14 @@
               </a:spcAft>
               <a:defRPr sz="1500">
                 <a:solidFill>
-                  <a:srgbClr val="333333"/>
-                </a:solidFill>
-              </a:defRPr>
-            </a:pPr>
-            <a:r>
+                  <a:srgbClr val="E0E0E0"/>
+                </a:solidFill>
+              </a:defRPr>
+            </a:pPr>
+            <a:r>
+              <a:rPr>
+                <a:solidFill/>
+              </a:rPr>
               <a:t>Data Center &amp; Campus (~$388K software)</a:t>
             </a:r>
           </a:p>
@@ -5480,11 +5739,14 @@
               </a:spcAft>
               <a:defRPr sz="1500">
                 <a:solidFill>
-                  <a:srgbClr val="333333"/>
-                </a:solidFill>
-              </a:defRPr>
-            </a:pPr>
-            <a:r>
+                  <a:srgbClr val="E0E0E0"/>
+                </a:solidFill>
+              </a:defRPr>
+            </a:pPr>
+            <a:r>
+              <a:rPr>
+                <a:solidFill/>
+              </a:rPr>
               <a:t>Nexus 9300 XF switches (30 in install base, 30 desired)</a:t>
             </a:r>
           </a:p>
@@ -5495,11 +5757,14 @@
               </a:spcAft>
               <a:defRPr sz="1500">
                 <a:solidFill>
-                  <a:srgbClr val="333333"/>
-                </a:solidFill>
-              </a:defRPr>
-            </a:pPr>
-            <a:r>
+                  <a:srgbClr val="E0E0E0"/>
+                </a:solidFill>
+              </a:defRPr>
+            </a:pPr>
+            <a:r>
+              <a:rPr>
+                <a:solidFill/>
+              </a:rPr>
               <a:t>Catalyst C9200/C9300/C9500 DNA EA licensing</a:t>
             </a:r>
           </a:p>
@@ -5510,11 +5775,14 @@
               </a:spcAft>
               <a:defRPr sz="1500">
                 <a:solidFill>
-                  <a:srgbClr val="333333"/>
-                </a:solidFill>
-              </a:defRPr>
-            </a:pPr>
-            <a:r>
+                  <a:srgbClr val="E0E0E0"/>
+                </a:solidFill>
+              </a:defRPr>
+            </a:pPr>
+            <a:r>
+              <a:rPr>
+                <a:solidFill/>
+              </a:rPr>
               <a:t>Cisco DNA Wireless (350 AP licenses)</a:t>
             </a:r>
           </a:p>
@@ -5525,11 +5793,14 @@
               </a:spcAft>
               <a:defRPr sz="1500">
                 <a:solidFill>
-                  <a:srgbClr val="333333"/>
-                </a:solidFill>
-              </a:defRPr>
-            </a:pPr>
-            <a:r>
+                  <a:srgbClr val="E0E0E0"/>
+                </a:solidFill>
+              </a:defRPr>
+            </a:pPr>
+            <a:r>
+              <a:rPr>
+                <a:solidFill/>
+              </a:rPr>
               <a:t>Secure Enterprise SD-WAN (Small/Medium tiers)</a:t>
             </a:r>
           </a:p>
@@ -5540,11 +5811,14 @@
               </a:spcAft>
               <a:defRPr sz="1500">
                 <a:solidFill>
-                  <a:srgbClr val="333333"/>
-                </a:solidFill>
-              </a:defRPr>
-            </a:pPr>
-            <a:r>
+                  <a:srgbClr val="E0E0E0"/>
+                </a:solidFill>
+              </a:defRPr>
+            </a:pPr>
+            <a:r>
+              <a:rPr>
+                <a:solidFill/>
+              </a:rPr>
               <a:t>Top Support Services</a:t>
             </a:r>
           </a:p>
@@ -5555,11 +5829,14 @@
               </a:spcAft>
               <a:defRPr sz="1500">
                 <a:solidFill>
-                  <a:srgbClr val="333333"/>
-                </a:solidFill>
-              </a:defRPr>
-            </a:pPr>
-            <a:r>
+                  <a:srgbClr val="E0E0E0"/>
+                </a:solidFill>
+              </a:defRPr>
+            </a:pPr>
+            <a:r>
+              <a:rPr>
+                <a:solidFill/>
+              </a:rPr>
               <a:t>Catalyst Switching 8x5xNBD: $473,061</a:t>
             </a:r>
           </a:p>
@@ -5570,11 +5847,14 @@
               </a:spcAft>
               <a:defRPr sz="1500">
                 <a:solidFill>
-                  <a:srgbClr val="333333"/>
-                </a:solidFill>
-              </a:defRPr>
-            </a:pPr>
-            <a:r>
+                  <a:srgbClr val="E0E0E0"/>
+                </a:solidFill>
+              </a:defRPr>
+            </a:pPr>
+            <a:r>
+              <a:rPr>
+                <a:solidFill/>
+              </a:rPr>
               <a:t>Catalyst Switching 24x7x4: $163,292</a:t>
             </a:r>
           </a:p>
@@ -5585,11 +5865,14 @@
               </a:spcAft>
               <a:defRPr sz="1500">
                 <a:solidFill>
-                  <a:srgbClr val="333333"/>
-                </a:solidFill>
-              </a:defRPr>
-            </a:pPr>
-            <a:r>
+                  <a:srgbClr val="E0E0E0"/>
+                </a:solidFill>
+              </a:defRPr>
+            </a:pPr>
+            <a:r>
+              <a:rPr>
+                <a:solidFill/>
+              </a:rPr>
               <a:t>Nexus Switching support: $154,000</a:t>
             </a:r>
           </a:p>
@@ -5600,11 +5883,14 @@
               </a:spcAft>
               <a:defRPr sz="1500">
                 <a:solidFill>
-                  <a:srgbClr val="333333"/>
-                </a:solidFill>
-              </a:defRPr>
-            </a:pPr>
-            <a:r>
+                  <a:srgbClr val="E0E0E0"/>
+                </a:solidFill>
+              </a:defRPr>
+            </a:pPr>
+            <a:r>
+              <a:rPr>
+                <a:solidFill/>
+              </a:rPr>
               <a:t>ENTWAN/SD-WAN support: $87,784</a:t>
             </a:r>
           </a:p>
@@ -5621,6 +5907,14 @@
 <file path=ppt/slides/slide5.xml><?xml version="1.0" encoding="utf-8"?>
 <p:sld xmlns:a="http://schemas.openxmlformats.org/drawingml/2006/main" xmlns:p="http://schemas.openxmlformats.org/presentationml/2006/main" xmlns:r="http://schemas.openxmlformats.org/officeDocument/2006/relationships">
   <p:cSld>
+    <p:bg>
+      <p:bgPr>
+        <a:solidFill>
+          <a:srgbClr val="1A2B4A"/>
+        </a:solidFill>
+        <a:effectLst/>
+      </p:bgPr>
+    </p:bg>
     <p:spTree>
       <p:nvGrpSpPr>
         <p:cNvPr id="1" name=""/>
@@ -5701,6 +5995,9 @@
               </a:defRPr>
             </a:pPr>
             <a:r>
+              <a:rPr>
+                <a:solidFill/>
+              </a:rPr>
               <a:t>Security Portfolio</a:t>
             </a:r>
           </a:p>
@@ -5731,11 +6028,14 @@
             <a:pPr>
               <a:defRPr sz="1400">
                 <a:solidFill>
-                  <a:srgbClr val="CCE8F7"/>
-                </a:solidFill>
-              </a:defRPr>
-            </a:pPr>
-            <a:r>
+                  <a:srgbClr val="243B5C"/>
+                </a:solidFill>
+              </a:defRPr>
+            </a:pPr>
+            <a:r>
+              <a:rPr>
+                <a:solidFill/>
+              </a:rPr>
               <a:t>Software TCV: $1,055,037  |  Services TCV: $285,205</a:t>
             </a:r>
           </a:p>
@@ -5779,6 +6079,9 @@
                         </a:defRPr>
                       </a:pPr>
                       <a:r>
+                        <a:rPr>
+                          <a:solidFill/>
+                        </a:rPr>
                         <a:t>Solution</a:t>
                       </a:r>
                     </a:p>
@@ -5802,6 +6105,9 @@
                         </a:defRPr>
                       </a:pPr>
                       <a:r>
+                        <a:rPr>
+                          <a:solidFill/>
+                        </a:rPr>
                         <a:t>Product</a:t>
                       </a:r>
                     </a:p>
@@ -5825,6 +6131,9 @@
                         </a:defRPr>
                       </a:pPr>
                       <a:r>
+                        <a:rPr>
+                          <a:solidFill/>
+                        </a:rPr>
                         <a:t>Qty</a:t>
                       </a:r>
                     </a:p>
@@ -5848,6 +6157,9 @@
                         </a:defRPr>
                       </a:pPr>
                       <a:r>
+                        <a:rPr>
+                          <a:solidFill/>
+                        </a:rPr>
                         <a:t>TCV (USD)</a:t>
                       </a:r>
                     </a:p>
@@ -5869,13 +6181,16 @@
                         <a:defRPr sz="1100"/>
                       </a:pPr>
                       <a:r>
+                        <a:rPr>
+                          <a:solidFill/>
+                        </a:rPr>
                         <a:t>SSE</a:t>
                       </a:r>
                     </a:p>
                   </a:txBody>
                   <a:tcPr>
                     <a:solidFill>
-                      <a:srgbClr val="F5F5F5"/>
+                      <a:srgbClr val="2D3A52"/>
                     </a:solidFill>
                   </a:tcPr>
                 </a:tc>
@@ -5888,13 +6203,16 @@
                         <a:defRPr sz="1100"/>
                       </a:pPr>
                       <a:r>
+                        <a:rPr>
+                          <a:solidFill/>
+                        </a:rPr>
                         <a:t>Cisco Secure Private Access Advantage</a:t>
                       </a:r>
                     </a:p>
                   </a:txBody>
                   <a:tcPr>
                     <a:solidFill>
-                      <a:srgbClr val="F5F5F5"/>
+                      <a:srgbClr val="2D3A52"/>
                     </a:solidFill>
                   </a:tcPr>
                 </a:tc>
@@ -5907,13 +6225,16 @@
                         <a:defRPr sz="1100"/>
                       </a:pPr>
                       <a:r>
+                        <a:rPr>
+                          <a:solidFill/>
+                        </a:rPr>
                         <a:t>3,000</a:t>
                       </a:r>
                     </a:p>
                   </a:txBody>
                   <a:tcPr>
                     <a:solidFill>
-                      <a:srgbClr val="F5F5F5"/>
+                      <a:srgbClr val="2D3A52"/>
                     </a:solidFill>
                   </a:tcPr>
                 </a:tc>
@@ -5926,13 +6247,16 @@
                         <a:defRPr sz="1100"/>
                       </a:pPr>
                       <a:r>
+                        <a:rPr>
+                          <a:solidFill/>
+                        </a:rPr>
                         <a:t>$408,815</a:t>
                       </a:r>
                     </a:p>
                   </a:txBody>
                   <a:tcPr>
                     <a:solidFill>
-                      <a:srgbClr val="F5F5F5"/>
+                      <a:srgbClr val="2D3A52"/>
                     </a:solidFill>
                   </a:tcPr>
                 </a:tc>
@@ -5947,6 +6271,9 @@
                         <a:defRPr sz="1100"/>
                       </a:pPr>
                       <a:r>
+                        <a:rPr>
+                          <a:solidFill/>
+                        </a:rPr>
                         <a:t>SSE</a:t>
                       </a:r>
                     </a:p>
@@ -5962,6 +6289,9 @@
                         <a:defRPr sz="1100"/>
                       </a:pPr>
                       <a:r>
+                        <a:rPr>
+                          <a:solidFill/>
+                        </a:rPr>
                         <a:t>Cisco Secure Internet Access Advantage</a:t>
                       </a:r>
                     </a:p>
@@ -5977,6 +6307,9 @@
                         <a:defRPr sz="1100"/>
                       </a:pPr>
                       <a:r>
+                        <a:rPr>
+                          <a:solidFill/>
+                        </a:rPr>
                         <a:t>3,000</a:t>
                       </a:r>
                     </a:p>
@@ -5992,6 +6325,9 @@
                         <a:defRPr sz="1100"/>
                       </a:pPr>
                       <a:r>
+                        <a:rPr>
+                          <a:solidFill/>
+                        </a:rPr>
                         <a:t>$282,766</a:t>
                       </a:r>
                     </a:p>
@@ -6009,13 +6345,16 @@
                         <a:defRPr sz="1100"/>
                       </a:pPr>
                       <a:r>
+                        <a:rPr>
+                          <a:solidFill/>
+                        </a:rPr>
                         <a:t>Zero Trust</a:t>
                       </a:r>
                     </a:p>
                   </a:txBody>
                   <a:tcPr>
                     <a:solidFill>
-                      <a:srgbClr val="F5F5F5"/>
+                      <a:srgbClr val="2D3A52"/>
                     </a:solidFill>
                   </a:tcPr>
                 </a:tc>
@@ -6028,13 +6367,16 @@
                         <a:defRPr sz="1100"/>
                       </a:pPr>
                       <a:r>
+                        <a:rPr>
+                          <a:solidFill/>
+                        </a:rPr>
                         <a:t>Duo Essentials (MFA)</a:t>
                       </a:r>
                     </a:p>
                   </a:txBody>
                   <a:tcPr>
                     <a:solidFill>
-                      <a:srgbClr val="F5F5F5"/>
+                      <a:srgbClr val="2D3A52"/>
                     </a:solidFill>
                   </a:tcPr>
                 </a:tc>
@@ -6047,13 +6389,16 @@
                         <a:defRPr sz="1100"/>
                       </a:pPr>
                       <a:r>
+                        <a:rPr>
+                          <a:solidFill/>
+                        </a:rPr>
                         <a:t>2,500</a:t>
                       </a:r>
                     </a:p>
                   </a:txBody>
                   <a:tcPr>
                     <a:solidFill>
-                      <a:srgbClr val="F5F5F5"/>
+                      <a:srgbClr val="2D3A52"/>
                     </a:solidFill>
                   </a:tcPr>
                 </a:tc>
@@ -6066,13 +6411,16 @@
                         <a:defRPr sz="1100"/>
                       </a:pPr>
                       <a:r>
+                        <a:rPr>
+                          <a:solidFill/>
+                        </a:rPr>
                         <a:t>$107,350</a:t>
                       </a:r>
                     </a:p>
                   </a:txBody>
                   <a:tcPr>
                     <a:solidFill>
-                      <a:srgbClr val="F5F5F5"/>
+                      <a:srgbClr val="2D3A52"/>
                     </a:solidFill>
                   </a:tcPr>
                 </a:tc>
@@ -6087,6 +6435,9 @@
                         <a:defRPr sz="1100"/>
                       </a:pPr>
                       <a:r>
+                        <a:rPr>
+                          <a:solidFill/>
+                        </a:rPr>
                         <a:t>Zero Trust</a:t>
                       </a:r>
                     </a:p>
@@ -6102,6 +6453,9 @@
                         <a:defRPr sz="1100"/>
                       </a:pPr>
                       <a:r>
+                        <a:rPr>
+                          <a:solidFill/>
+                        </a:rPr>
                         <a:t>ISE Advantage</a:t>
                       </a:r>
                     </a:p>
@@ -6117,6 +6471,9 @@
                         <a:defRPr sz="1100"/>
                       </a:pPr>
                       <a:r>
+                        <a:rPr>
+                          <a:solidFill/>
+                        </a:rPr>
                         <a:t>8,000</a:t>
                       </a:r>
                     </a:p>
@@ -6132,6 +6489,9 @@
                         <a:defRPr sz="1100"/>
                       </a:pPr>
                       <a:r>
+                        <a:rPr>
+                          <a:solidFill/>
+                        </a:rPr>
                         <a:t>$28,200</a:t>
                       </a:r>
                     </a:p>
@@ -6149,13 +6509,16 @@
                         <a:defRPr sz="1100"/>
                       </a:pPr>
                       <a:r>
+                        <a:rPr>
+                          <a:solidFill/>
+                        </a:rPr>
                         <a:t>Firewall</a:t>
                       </a:r>
                     </a:p>
                   </a:txBody>
                   <a:tcPr>
                     <a:solidFill>
-                      <a:srgbClr val="F5F5F5"/>
+                      <a:srgbClr val="2D3A52"/>
                     </a:solidFill>
                   </a:tcPr>
                 </a:tc>
@@ -6168,13 +6531,16 @@
                         <a:defRPr sz="1100"/>
                       </a:pPr>
                       <a:r>
+                        <a:rPr>
+                          <a:solidFill/>
+                        </a:rPr>
                         <a:t>Secure Firewall Threat Defense (FTD)</a:t>
                       </a:r>
                     </a:p>
                   </a:txBody>
                   <a:tcPr>
                     <a:solidFill>
-                      <a:srgbClr val="F5F5F5"/>
+                      <a:srgbClr val="2D3A52"/>
                     </a:solidFill>
                   </a:tcPr>
                 </a:tc>
@@ -6187,13 +6553,16 @@
                         <a:defRPr sz="1100"/>
                       </a:pPr>
                       <a:r>
+                        <a:rPr>
+                          <a:solidFill/>
+                        </a:rPr>
                         <a:t>45 devices</a:t>
                       </a:r>
                     </a:p>
                   </a:txBody>
                   <a:tcPr>
                     <a:solidFill>
-                      <a:srgbClr val="F5F5F5"/>
+                      <a:srgbClr val="2D3A52"/>
                     </a:solidFill>
                   </a:tcPr>
                 </a:tc>
@@ -6206,13 +6575,16 @@
                         <a:defRPr sz="1100"/>
                       </a:pPr>
                       <a:r>
+                        <a:rPr>
+                          <a:solidFill/>
+                        </a:rPr>
                         <a:t>$158,127</a:t>
                       </a:r>
                     </a:p>
                   </a:txBody>
                   <a:tcPr>
                     <a:solidFill>
-                      <a:srgbClr val="F5F5F5"/>
+                      <a:srgbClr val="2D3A52"/>
                     </a:solidFill>
                   </a:tcPr>
                 </a:tc>
@@ -6227,6 +6599,9 @@
                         <a:defRPr sz="1100"/>
                       </a:pPr>
                       <a:r>
+                        <a:rPr>
+                          <a:solidFill/>
+                        </a:rPr>
                         <a:t>Add-ons</a:t>
                       </a:r>
                     </a:p>
@@ -6242,6 +6617,9 @@
                         <a:defRPr sz="1100"/>
                       </a:pPr>
                       <a:r>
+                        <a:rPr>
+                          <a:solidFill/>
+                        </a:rPr>
                         <a:t>Secure Client Premier + FWM Cloud Mgmt</a:t>
                       </a:r>
                     </a:p>
@@ -6257,6 +6635,9 @@
                         <a:defRPr sz="1100"/>
                       </a:pPr>
                       <a:r>
+                        <a:rPr>
+                          <a:solidFill/>
+                        </a:rPr>
                         <a:t>—</a:t>
                       </a:r>
                     </a:p>
@@ -6272,6 +6653,9 @@
                         <a:defRPr sz="1100"/>
                       </a:pPr>
                       <a:r>
+                        <a:rPr>
+                          <a:solidFill/>
+                        </a:rPr>
                         <a:t>$27,419</a:t>
                       </a:r>
                     </a:p>
@@ -6311,11 +6695,14 @@
               </a:spcAft>
               <a:defRPr sz="1400">
                 <a:solidFill>
-                  <a:srgbClr val="333333"/>
-                </a:solidFill>
-              </a:defRPr>
-            </a:pPr>
-            <a:r>
+                  <a:srgbClr val="E0E0E0"/>
+                </a:solidFill>
+              </a:defRPr>
+            </a:pPr>
+            <a:r>
+              <a:rPr>
+                <a:solidFill/>
+              </a:rPr>
               <a:t>Security Content Users (SCU): 1,000</a:t>
             </a:r>
           </a:p>
@@ -6326,11 +6713,14 @@
               </a:spcAft>
               <a:defRPr sz="1400">
                 <a:solidFill>
-                  <a:srgbClr val="333333"/>
-                </a:solidFill>
-              </a:defRPr>
-            </a:pPr>
-            <a:r>
+                  <a:srgbClr val="E0E0E0"/>
+                </a:solidFill>
+              </a:defRPr>
+            </a:pPr>
+            <a:r>
+              <a:rPr>
+                <a:solidFill/>
+              </a:rPr>
               <a:t>Firewall models: FPR1010T through FPR3110T</a:t>
             </a:r>
           </a:p>
@@ -6341,11 +6731,14 @@
               </a:spcAft>
               <a:defRPr sz="1400">
                 <a:solidFill>
-                  <a:srgbClr val="333333"/>
-                </a:solidFill>
-              </a:defRPr>
-            </a:pPr>
-            <a:r>
+                  <a:srgbClr val="E0E0E0"/>
+                </a:solidFill>
+              </a:defRPr>
+            </a:pPr>
+            <a:r>
+              <a:rPr>
+                <a:solidFill/>
+              </a:rPr>
               <a:t>Top security services: Secure Access support ($148K), SFW support ($75K), ISE support ($47K)</a:t>
             </a:r>
           </a:p>
@@ -6362,6 +6755,14 @@
 <file path=ppt/slides/slide6.xml><?xml version="1.0" encoding="utf-8"?>
 <p:sld xmlns:a="http://schemas.openxmlformats.org/drawingml/2006/main" xmlns:p="http://schemas.openxmlformats.org/presentationml/2006/main" xmlns:r="http://schemas.openxmlformats.org/officeDocument/2006/relationships">
   <p:cSld>
+    <p:bg>
+      <p:bgPr>
+        <a:solidFill>
+          <a:srgbClr val="1A2B4A"/>
+        </a:solidFill>
+        <a:effectLst/>
+      </p:bgPr>
+    </p:bg>
     <p:spTree>
       <p:nvGrpSpPr>
         <p:cNvPr id="1" name=""/>
@@ -6442,6 +6843,9 @@
               </a:defRPr>
             </a:pPr>
             <a:r>
+              <a:rPr>
+                <a:solidFill/>
+              </a:rPr>
               <a:t>Applications Infrastructure</a:t>
             </a:r>
           </a:p>
@@ -6472,11 +6876,14 @@
             <a:pPr>
               <a:defRPr sz="1400">
                 <a:solidFill>
-                  <a:srgbClr val="CCE8F7"/>
-                </a:solidFill>
-              </a:defRPr>
-            </a:pPr>
-            <a:r>
+                  <a:srgbClr val="243B5C"/>
+                </a:solidFill>
+              </a:defRPr>
+            </a:pPr>
+            <a:r>
+              <a:rPr>
+                <a:solidFill/>
+              </a:rPr>
               <a:t>Software TCV: $69,258</a:t>
             </a:r>
           </a:p>
@@ -6510,11 +6917,14 @@
               </a:spcAft>
               <a:defRPr sz="1600">
                 <a:solidFill>
-                  <a:srgbClr val="333333"/>
-                </a:solidFill>
-              </a:defRPr>
-            </a:pPr>
-            <a:r>
+                  <a:srgbClr val="E0E0E0"/>
+                </a:solidFill>
+              </a:defRPr>
+            </a:pPr>
+            <a:r>
+              <a:rPr>
+                <a:solidFill/>
+              </a:rPr>
               <a:t>ThousandEyes — Full Stack Observability</a:t>
             </a:r>
           </a:p>
@@ -6525,11 +6935,14 @@
               </a:spcAft>
               <a:defRPr sz="1600">
                 <a:solidFill>
-                  <a:srgbClr val="333333"/>
-                </a:solidFill>
-              </a:defRPr>
-            </a:pPr>
-            <a:r>
+                  <a:srgbClr val="E0E0E0"/>
+                </a:solidFill>
+              </a:defRPr>
+            </a:pPr>
+            <a:r>
+              <a:rPr>
+                <a:solidFill/>
+              </a:rPr>
               <a:t>Part Number: E3A-TE-UNITS</a:t>
             </a:r>
           </a:p>
@@ -6540,11 +6953,14 @@
               </a:spcAft>
               <a:defRPr sz="1600">
                 <a:solidFill>
-                  <a:srgbClr val="333333"/>
-                </a:solidFill>
-              </a:defRPr>
-            </a:pPr>
-            <a:r>
+                  <a:srgbClr val="E0E0E0"/>
+                </a:solidFill>
+              </a:defRPr>
+            </a:pPr>
+            <a:r>
+              <a:rPr>
+                <a:solidFill/>
+              </a:rPr>
               <a:t>Quantity: 4,000 Cloud and Enterprise Agents</a:t>
             </a:r>
           </a:p>
@@ -6555,11 +6971,14 @@
               </a:spcAft>
               <a:defRPr sz="1600">
                 <a:solidFill>
-                  <a:srgbClr val="333333"/>
-                </a:solidFill>
-              </a:defRPr>
-            </a:pPr>
-            <a:r>
+                  <a:srgbClr val="E0E0E0"/>
+                </a:solidFill>
+              </a:defRPr>
+            </a:pPr>
+            <a:r>
+              <a:rPr>
+                <a:solidFill/>
+              </a:rPr>
               <a:t>Install Base: 2,500  →  Desired: 4,000 (net increase of 1,500 agents)</a:t>
             </a:r>
           </a:p>
@@ -6570,11 +6989,14 @@
               </a:spcAft>
               <a:defRPr sz="1600">
                 <a:solidFill>
-                  <a:srgbClr val="333333"/>
-                </a:solidFill>
-              </a:defRPr>
-            </a:pPr>
-            <a:r>
+                  <a:srgbClr val="E0E0E0"/>
+                </a:solidFill>
+              </a:defRPr>
+            </a:pPr>
+            <a:r>
+              <a:rPr>
+                <a:solidFill/>
+              </a:rPr>
               <a:t>Total Contract Value: $69,258 over 36 months</a:t>
             </a:r>
           </a:p>
@@ -6585,11 +7007,14 @@
               </a:spcAft>
               <a:defRPr sz="1600">
                 <a:solidFill>
-                  <a:srgbClr val="333333"/>
-                </a:solidFill>
-              </a:defRPr>
-            </a:pPr>
-            <a:r>
+                  <a:srgbClr val="E0E0E0"/>
+                </a:solidFill>
+              </a:defRPr>
+            </a:pPr>
+            <a:r>
+              <a:rPr>
+                <a:solidFill/>
+              </a:rPr>
               <a:t>Use Cases</a:t>
             </a:r>
           </a:p>
@@ -6600,11 +7025,14 @@
               </a:spcAft>
               <a:defRPr sz="1600">
                 <a:solidFill>
-                  <a:srgbClr val="333333"/>
-                </a:solidFill>
-              </a:defRPr>
-            </a:pPr>
-            <a:r>
+                  <a:srgbClr val="E0E0E0"/>
+                </a:solidFill>
+              </a:defRPr>
+            </a:pPr>
+            <a:r>
+              <a:rPr>
+                <a:solidFill/>
+              </a:rPr>
               <a:t>End-to-end visibility across SaaS, cloud, and on-premises applications</a:t>
             </a:r>
           </a:p>
@@ -6615,11 +7043,14 @@
               </a:spcAft>
               <a:defRPr sz="1600">
                 <a:solidFill>
-                  <a:srgbClr val="333333"/>
-                </a:solidFill>
-              </a:defRPr>
-            </a:pPr>
-            <a:r>
+                  <a:srgbClr val="E0E0E0"/>
+                </a:solidFill>
+              </a:defRPr>
+            </a:pPr>
+            <a:r>
+              <a:rPr>
+                <a:solidFill/>
+              </a:rPr>
               <a:t>Proactive monitoring of network paths and application performance</a:t>
             </a:r>
           </a:p>
@@ -6630,11 +7061,14 @@
               </a:spcAft>
               <a:defRPr sz="1600">
                 <a:solidFill>
-                  <a:srgbClr val="333333"/>
-                </a:solidFill>
-              </a:defRPr>
-            </a:pPr>
-            <a:r>
+                  <a:srgbClr val="E0E0E0"/>
+                </a:solidFill>
+              </a:defRPr>
+            </a:pPr>
+            <a:r>
+              <a:rPr>
+                <a:solidFill/>
+              </a:rPr>
               <a:t>Digital experience monitoring for distributed workforce and facilities</a:t>
             </a:r>
           </a:p>
@@ -6651,6 +7085,14 @@
 <file path=ppt/slides/slide7.xml><?xml version="1.0" encoding="utf-8"?>
 <p:sld xmlns:a="http://schemas.openxmlformats.org/drawingml/2006/main" xmlns:p="http://schemas.openxmlformats.org/presentationml/2006/main" xmlns:r="http://schemas.openxmlformats.org/officeDocument/2006/relationships">
   <p:cSld>
+    <p:bg>
+      <p:bgPr>
+        <a:solidFill>
+          <a:srgbClr val="1A2B4A"/>
+        </a:solidFill>
+        <a:effectLst/>
+      </p:bgPr>
+    </p:bg>
     <p:spTree>
       <p:nvGrpSpPr>
         <p:cNvPr id="1" name=""/>
@@ -6731,6 +7173,9 @@
               </a:defRPr>
             </a:pPr>
             <a:r>
+              <a:rPr>
+                <a:solidFill/>
+              </a:rPr>
               <a:t>Support &amp; Lifecycle Services</a:t>
             </a:r>
           </a:p>
@@ -6761,11 +7206,14 @@
             <a:pPr>
               <a:defRPr sz="1400">
                 <a:solidFill>
-                  <a:srgbClr val="CCE8F7"/>
-                </a:solidFill>
-              </a:defRPr>
-            </a:pPr>
-            <a:r>
+                  <a:srgbClr val="243B5C"/>
+                </a:solidFill>
+              </a:defRPr>
+            </a:pPr>
+            <a:r>
+              <a:rPr>
+                <a:solidFill/>
+              </a:rPr>
               <a:t>Total Services TCV: $1,241,084</a:t>
             </a:r>
           </a:p>
@@ -6808,6 +7256,9 @@
                         </a:defRPr>
                       </a:pPr>
                       <a:r>
+                        <a:rPr>
+                          <a:solidFill/>
+                        </a:rPr>
                         <a:t>Category</a:t>
                       </a:r>
                     </a:p>
@@ -6831,6 +7282,9 @@
                         </a:defRPr>
                       </a:pPr>
                       <a:r>
+                        <a:rPr>
+                          <a:solidFill/>
+                        </a:rPr>
                         <a:t>Coverage Area</a:t>
                       </a:r>
                     </a:p>
@@ -6854,6 +7308,9 @@
                         </a:defRPr>
                       </a:pPr>
                       <a:r>
+                        <a:rPr>
+                          <a:solidFill/>
+                        </a:rPr>
                         <a:t>TCV (USD)</a:t>
                       </a:r>
                     </a:p>
@@ -6875,13 +7332,16 @@
                         <a:defRPr sz="1100"/>
                       </a:pPr>
                       <a:r>
+                        <a:rPr>
+                          <a:solidFill/>
+                        </a:rPr>
                         <a:t>Networking</a:t>
                       </a:r>
                     </a:p>
                   </a:txBody>
                   <a:tcPr>
                     <a:solidFill>
-                      <a:srgbClr val="F5F5F5"/>
+                      <a:srgbClr val="2D3A52"/>
                     </a:solidFill>
                   </a:tcPr>
                 </a:tc>
@@ -6894,13 +7354,16 @@
                         <a:defRPr sz="1100"/>
                       </a:pPr>
                       <a:r>
+                        <a:rPr>
+                          <a:solidFill/>
+                        </a:rPr>
                         <a:t>Catalyst Switching (877 NBD + 64 24x7)</a:t>
                       </a:r>
                     </a:p>
                   </a:txBody>
                   <a:tcPr>
                     <a:solidFill>
-                      <a:srgbClr val="F5F5F5"/>
+                      <a:srgbClr val="2D3A52"/>
                     </a:solidFill>
                   </a:tcPr>
                 </a:tc>
@@ -6913,13 +7376,16 @@
                         <a:defRPr sz="1100"/>
                       </a:pPr>
                       <a:r>
+                        <a:rPr>
+                          <a:solidFill/>
+                        </a:rPr>
                         <a:t>$636,352</a:t>
                       </a:r>
                     </a:p>
                   </a:txBody>
                   <a:tcPr>
                     <a:solidFill>
-                      <a:srgbClr val="F5F5F5"/>
+                      <a:srgbClr val="2D3A52"/>
                     </a:solidFill>
                   </a:tcPr>
                 </a:tc>
@@ -6934,6 +7400,9 @@
                         <a:defRPr sz="1100"/>
                       </a:pPr>
                       <a:r>
+                        <a:rPr>
+                          <a:solidFill/>
+                        </a:rPr>
                         <a:t>Networking</a:t>
                       </a:r>
                     </a:p>
@@ -6949,6 +7418,9 @@
                         <a:defRPr sz="1100"/>
                       </a:pPr>
                       <a:r>
+                        <a:rPr>
+                          <a:solidFill/>
+                        </a:rPr>
                         <a:t>Nexus Switching (38 NBD + 16 24x7)</a:t>
                       </a:r>
                     </a:p>
@@ -6964,6 +7436,9 @@
                         <a:defRPr sz="1100"/>
                       </a:pPr>
                       <a:r>
+                        <a:rPr>
+                          <a:solidFill/>
+                        </a:rPr>
                         <a:t>$154,000</a:t>
                       </a:r>
                     </a:p>
@@ -6981,13 +7456,16 @@
                         <a:defRPr sz="1100"/>
                       </a:pPr>
                       <a:r>
+                        <a:rPr>
+                          <a:solidFill/>
+                        </a:rPr>
                         <a:t>Networking</a:t>
                       </a:r>
                     </a:p>
                   </a:txBody>
                   <a:tcPr>
                     <a:solidFill>
-                      <a:srgbClr val="F5F5F5"/>
+                      <a:srgbClr val="2D3A52"/>
                     </a:solidFill>
                   </a:tcPr>
                 </a:tc>
@@ -7000,13 +7478,16 @@
                         <a:defRPr sz="1100"/>
                       </a:pPr>
                       <a:r>
+                        <a:rPr>
+                          <a:solidFill/>
+                        </a:rPr>
                         <a:t>ENTWAN / SD-WAN</a:t>
                       </a:r>
                     </a:p>
                   </a:txBody>
                   <a:tcPr>
                     <a:solidFill>
-                      <a:srgbClr val="F5F5F5"/>
+                      <a:srgbClr val="2D3A52"/>
                     </a:solidFill>
                   </a:tcPr>
                 </a:tc>
@@ -7019,13 +7500,16 @@
                         <a:defRPr sz="1100"/>
                       </a:pPr>
                       <a:r>
+                        <a:rPr>
+                          <a:solidFill/>
+                        </a:rPr>
                         <a:t>$87,784</a:t>
                       </a:r>
                     </a:p>
                   </a:txBody>
                   <a:tcPr>
                     <a:solidFill>
-                      <a:srgbClr val="F5F5F5"/>
+                      <a:srgbClr val="2D3A52"/>
                     </a:solidFill>
                   </a:tcPr>
                 </a:tc>
@@ -7040,6 +7524,9 @@
                         <a:defRPr sz="1100"/>
                       </a:pPr>
                       <a:r>
+                        <a:rPr>
+                          <a:solidFill/>
+                        </a:rPr>
                         <a:t>Networking</a:t>
                       </a:r>
                     </a:p>
@@ -7055,6 +7542,9 @@
                         <a:defRPr sz="1100"/>
                       </a:pPr>
                       <a:r>
+                        <a:rPr>
+                          <a:solidFill/>
+                        </a:rPr>
                         <a:t>Wireless, SAN, Perpetual SW</a:t>
                       </a:r>
                     </a:p>
@@ -7070,6 +7560,9 @@
                         <a:defRPr sz="1100"/>
                       </a:pPr>
                       <a:r>
+                        <a:rPr>
+                          <a:solidFill/>
+                        </a:rPr>
                         <a:t>$32,495</a:t>
                       </a:r>
                     </a:p>
@@ -7087,13 +7580,16 @@
                         <a:defRPr sz="1100"/>
                       </a:pPr>
                       <a:r>
+                        <a:rPr>
+                          <a:solidFill/>
+                        </a:rPr>
                         <a:t>Security</a:t>
                       </a:r>
                     </a:p>
                   </a:txBody>
                   <a:tcPr>
                     <a:solidFill>
-                      <a:srgbClr val="F5F5F5"/>
+                      <a:srgbClr val="2D3A52"/>
                     </a:solidFill>
                   </a:tcPr>
                 </a:tc>
@@ -7106,13 +7602,16 @@
                         <a:defRPr sz="1100"/>
                       </a:pPr>
                       <a:r>
+                        <a:rPr>
+                          <a:solidFill/>
+                        </a:rPr>
                         <a:t>Cisco Secure Access Advantage</a:t>
                       </a:r>
                     </a:p>
                   </a:txBody>
                   <a:tcPr>
                     <a:solidFill>
-                      <a:srgbClr val="F5F5F5"/>
+                      <a:srgbClr val="2D3A52"/>
                     </a:solidFill>
                   </a:tcPr>
                 </a:tc>
@@ -7125,13 +7624,16 @@
                         <a:defRPr sz="1100"/>
                       </a:pPr>
                       <a:r>
+                        <a:rPr>
+                          <a:solidFill/>
+                        </a:rPr>
                         <a:t>$147,689</a:t>
                       </a:r>
                     </a:p>
                   </a:txBody>
                   <a:tcPr>
                     <a:solidFill>
-                      <a:srgbClr val="F5F5F5"/>
+                      <a:srgbClr val="2D3A52"/>
                     </a:solidFill>
                   </a:tcPr>
                 </a:tc>
@@ -7146,6 +7648,9 @@
                         <a:defRPr sz="1100"/>
                       </a:pPr>
                       <a:r>
+                        <a:rPr>
+                          <a:solidFill/>
+                        </a:rPr>
                         <a:t>Security</a:t>
                       </a:r>
                     </a:p>
@@ -7161,6 +7666,9 @@
                         <a:defRPr sz="1100"/>
                       </a:pPr>
                       <a:r>
+                        <a:rPr>
+                          <a:solidFill/>
+                        </a:rPr>
                         <a:t>Secure Firewall (NBD, 24x7, SW, Perpetual)</a:t>
                       </a:r>
                     </a:p>
@@ -7176,6 +7684,9 @@
                         <a:defRPr sz="1100"/>
                       </a:pPr>
                       <a:r>
+                        <a:rPr>
+                          <a:solidFill/>
+                        </a:rPr>
                         <a:t>$75,716</a:t>
                       </a:r>
                     </a:p>
@@ -7193,13 +7704,16 @@
                         <a:defRPr sz="1100"/>
                       </a:pPr>
                       <a:r>
+                        <a:rPr>
+                          <a:solidFill/>
+                        </a:rPr>
                         <a:t>Security</a:t>
                       </a:r>
                     </a:p>
                   </a:txBody>
                   <a:tcPr>
                     <a:solidFill>
-                      <a:srgbClr val="F5F5F5"/>
+                      <a:srgbClr val="2D3A52"/>
                     </a:solidFill>
                   </a:tcPr>
                 </a:tc>
@@ -7212,13 +7726,16 @@
                         <a:defRPr sz="1100"/>
                       </a:pPr>
                       <a:r>
+                        <a:rPr>
+                          <a:solidFill/>
+                        </a:rPr>
                         <a:t>ISE + Duo Essentials</a:t>
                       </a:r>
                     </a:p>
                   </a:txBody>
                   <a:tcPr>
                     <a:solidFill>
-                      <a:srgbClr val="F5F5F5"/>
+                      <a:srgbClr val="2D3A52"/>
                     </a:solidFill>
                   </a:tcPr>
                 </a:tc>
@@ -7231,13 +7748,16 @@
                         <a:defRPr sz="1100"/>
                       </a:pPr>
                       <a:r>
+                        <a:rPr>
+                          <a:solidFill/>
+                        </a:rPr>
                         <a:t>$31,451</a:t>
                       </a:r>
                     </a:p>
                   </a:txBody>
                   <a:tcPr>
                     <a:solidFill>
-                      <a:srgbClr val="F5F5F5"/>
+                      <a:srgbClr val="2D3A52"/>
                     </a:solidFill>
                   </a:tcPr>
                 </a:tc>
@@ -7257,6 +7777,14 @@
 <file path=ppt/slides/slide8.xml><?xml version="1.0" encoding="utf-8"?>
 <p:sld xmlns:a="http://schemas.openxmlformats.org/drawingml/2006/main" xmlns:p="http://schemas.openxmlformats.org/presentationml/2006/main" xmlns:r="http://schemas.openxmlformats.org/officeDocument/2006/relationships">
   <p:cSld>
+    <p:bg>
+      <p:bgPr>
+        <a:solidFill>
+          <a:srgbClr val="1A2B4A"/>
+        </a:solidFill>
+        <a:effectLst/>
+      </p:bgPr>
+    </p:bg>
     <p:spTree>
       <p:nvGrpSpPr>
         <p:cNvPr id="1" name=""/>
@@ -7337,6 +7865,9 @@
               </a:defRPr>
             </a:pPr>
             <a:r>
+              <a:rPr>
+                <a:solidFill/>
+              </a:rPr>
               <a:t>Annual Cost Breakdown</a:t>
             </a:r>
           </a:p>
@@ -7367,11 +7898,14 @@
             <a:pPr>
               <a:defRPr sz="1400">
                 <a:solidFill>
-                  <a:srgbClr val="CCE8F7"/>
-                </a:solidFill>
-              </a:defRPr>
-            </a:pPr>
-            <a:r>
+                  <a:srgbClr val="243B5C"/>
+                </a:solidFill>
+              </a:defRPr>
+            </a:pPr>
+            <a:r>
+              <a:rPr>
+                <a:solidFill/>
+              </a:rPr>
               <a:t>Based on 36-month term with annual billing</a:t>
             </a:r>
           </a:p>
@@ -7414,6 +7948,9 @@
                         </a:defRPr>
                       </a:pPr>
                       <a:r>
+                        <a:rPr>
+                          <a:solidFill/>
+                        </a:rPr>
                         <a:t>Category</a:t>
                       </a:r>
                     </a:p>
@@ -7437,6 +7974,9 @@
                         </a:defRPr>
                       </a:pPr>
                       <a:r>
+                        <a:rPr>
+                          <a:solidFill/>
+                        </a:rPr>
                         <a:t>3-Year TCV</a:t>
                       </a:r>
                     </a:p>
@@ -7460,6 +8000,9 @@
                         </a:defRPr>
                       </a:pPr>
                       <a:r>
+                        <a:rPr>
+                          <a:solidFill/>
+                        </a:rPr>
                         <a:t>Estimated Annual</a:t>
                       </a:r>
                     </a:p>
@@ -7481,13 +8024,16 @@
                         <a:defRPr sz="1100"/>
                       </a:pPr>
                       <a:r>
+                        <a:rPr>
+                          <a:solidFill/>
+                        </a:rPr>
                         <a:t>Software Subscriptions</a:t>
                       </a:r>
                     </a:p>
                   </a:txBody>
                   <a:tcPr>
                     <a:solidFill>
-                      <a:srgbClr val="F5F5F5"/>
+                      <a:srgbClr val="2D3A52"/>
                     </a:solidFill>
                   </a:tcPr>
                 </a:tc>
@@ -7500,13 +8046,16 @@
                         <a:defRPr sz="1100"/>
                       </a:pPr>
                       <a:r>
+                        <a:rPr>
+                          <a:solidFill/>
+                        </a:rPr>
                         <a:t>$1,764,058</a:t>
                       </a:r>
                     </a:p>
                   </a:txBody>
                   <a:tcPr>
                     <a:solidFill>
-                      <a:srgbClr val="F5F5F5"/>
+                      <a:srgbClr val="2D3A52"/>
                     </a:solidFill>
                   </a:tcPr>
                 </a:tc>
@@ -7519,13 +8068,16 @@
                         <a:defRPr sz="1100"/>
                       </a:pPr>
                       <a:r>
+                        <a:rPr>
+                          <a:solidFill/>
+                        </a:rPr>
                         <a:t>$588,019</a:t>
                       </a:r>
                     </a:p>
                   </a:txBody>
                   <a:tcPr>
                     <a:solidFill>
-                      <a:srgbClr val="F5F5F5"/>
+                      <a:srgbClr val="2D3A52"/>
                     </a:solidFill>
                   </a:tcPr>
                 </a:tc>
@@ -7540,6 +8092,9 @@
                         <a:defRPr sz="1100"/>
                       </a:pPr>
                       <a:r>
+                        <a:rPr>
+                          <a:solidFill/>
+                        </a:rPr>
                         <a:t>Support &amp; Lifecycle Services</a:t>
                       </a:r>
                     </a:p>
@@ -7555,6 +8110,9 @@
                         <a:defRPr sz="1100"/>
                       </a:pPr>
                       <a:r>
+                        <a:rPr>
+                          <a:solidFill/>
+                        </a:rPr>
                         <a:t>$1,241,084</a:t>
                       </a:r>
                     </a:p>
@@ -7570,6 +8128,9 @@
                         <a:defRPr sz="1100"/>
                       </a:pPr>
                       <a:r>
+                        <a:rPr>
+                          <a:solidFill/>
+                        </a:rPr>
                         <a:t>$413,695</a:t>
                       </a:r>
                     </a:p>
@@ -7587,13 +8148,16 @@
                         <a:defRPr sz="1100"/>
                       </a:pPr>
                       <a:r>
+                        <a:rPr>
+                          <a:solidFill/>
+                        </a:rPr>
                         <a:t>TOTAL</a:t>
                       </a:r>
                     </a:p>
                   </a:txBody>
                   <a:tcPr>
                     <a:solidFill>
-                      <a:srgbClr val="F5F5F5"/>
+                      <a:srgbClr val="2D3A52"/>
                     </a:solidFill>
                   </a:tcPr>
                 </a:tc>
@@ -7606,13 +8170,16 @@
                         <a:defRPr sz="1100"/>
                       </a:pPr>
                       <a:r>
+                        <a:rPr>
+                          <a:solidFill/>
+                        </a:rPr>
                         <a:t>$3,005,143</a:t>
                       </a:r>
                     </a:p>
                   </a:txBody>
                   <a:tcPr>
                     <a:solidFill>
-                      <a:srgbClr val="F5F5F5"/>
+                      <a:srgbClr val="2D3A52"/>
                     </a:solidFill>
                   </a:tcPr>
                 </a:tc>
@@ -7625,13 +8192,16 @@
                         <a:defRPr sz="1100"/>
                       </a:pPr>
                       <a:r>
+                        <a:rPr>
+                          <a:solidFill/>
+                        </a:rPr>
                         <a:t>$1,001,714</a:t>
                       </a:r>
                     </a:p>
                   </a:txBody>
                   <a:tcPr>
                     <a:solidFill>
-                      <a:srgbClr val="F5F5F5"/>
+                      <a:srgbClr val="2D3A52"/>
                     </a:solidFill>
                   </a:tcPr>
                 </a:tc>
@@ -7668,11 +8238,14 @@
               </a:spcAft>
               <a:defRPr sz="1500">
                 <a:solidFill>
-                  <a:srgbClr val="333333"/>
-                </a:solidFill>
-              </a:defRPr>
-            </a:pPr>
-            <a:r>
+                  <a:srgbClr val="E0E0E0"/>
+                </a:solidFill>
+              </a:defRPr>
+            </a:pPr>
+            <a:r>
+              <a:rPr>
+                <a:solidFill/>
+              </a:rPr>
               <a:t>Approximate annual spend: $1,001,714/year</a:t>
             </a:r>
           </a:p>
@@ -7683,11 +8256,14 @@
               </a:spcAft>
               <a:defRPr sz="1500">
                 <a:solidFill>
-                  <a:srgbClr val="333333"/>
-                </a:solidFill>
-              </a:defRPr>
-            </a:pPr>
-            <a:r>
+                  <a:srgbClr val="E0E0E0"/>
+                </a:solidFill>
+              </a:defRPr>
+            </a:pPr>
+            <a:r>
+              <a:rPr>
+                <a:solidFill/>
+              </a:rPr>
               <a:t>Billing model: Annual (invoiced yearly over 3-year term)</a:t>
             </a:r>
           </a:p>
@@ -7698,11 +8274,14 @@
               </a:spcAft>
               <a:defRPr sz="1500">
                 <a:solidFill>
-                  <a:srgbClr val="333333"/>
-                </a:solidFill>
-              </a:defRPr>
-            </a:pPr>
-            <a:r>
+                  <a:srgbClr val="E0E0E0"/>
+                </a:solidFill>
+              </a:defRPr>
+            </a:pPr>
+            <a:r>
+              <a:rPr>
+                <a:solidFill/>
+              </a:rPr>
               <a:t>Programmatic discounts applied: ~10% on most EA 3.0 subscriptions</a:t>
             </a:r>
           </a:p>
@@ -7713,11 +8292,14 @@
               </a:spcAft>
               <a:defRPr sz="1500">
                 <a:solidFill>
-                  <a:srgbClr val="333333"/>
-                </a:solidFill>
-              </a:defRPr>
-            </a:pPr>
-            <a:r>
+                  <a:srgbClr val="E0E0E0"/>
+                </a:solidFill>
+              </a:defRPr>
+            </a:pPr>
+            <a:r>
+              <a:rPr>
+                <a:solidFill/>
+              </a:rPr>
               <a:t>Pre-EA install base assets consumed upon EA activation</a:t>
             </a:r>
           </a:p>
@@ -7734,6 +8316,14 @@
 <file path=ppt/slides/slide9.xml><?xml version="1.0" encoding="utf-8"?>
 <p:sld xmlns:a="http://schemas.openxmlformats.org/drawingml/2006/main" xmlns:p="http://schemas.openxmlformats.org/presentationml/2006/main" xmlns:r="http://schemas.openxmlformats.org/officeDocument/2006/relationships">
   <p:cSld>
+    <p:bg>
+      <p:bgPr>
+        <a:solidFill>
+          <a:srgbClr val="1A2B4A"/>
+        </a:solidFill>
+        <a:effectLst/>
+      </p:bgPr>
+    </p:bg>
     <p:spTree>
       <p:nvGrpSpPr>
         <p:cNvPr id="1" name=""/>
@@ -7814,6 +8404,9 @@
               </a:defRPr>
             </a:pPr>
             <a:r>
+              <a:rPr>
+                <a:solidFill/>
+              </a:rPr>
               <a:t>Portfolios Not in Scope</a:t>
             </a:r>
           </a:p>
@@ -7847,11 +8440,14 @@
               </a:spcAft>
               <a:defRPr sz="1800">
                 <a:solidFill>
-                  <a:srgbClr val="333333"/>
-                </a:solidFill>
-              </a:defRPr>
-            </a:pPr>
-            <a:r>
+                  <a:srgbClr val="E0E0E0"/>
+                </a:solidFill>
+              </a:defRPr>
+            </a:pPr>
+            <a:r>
+              <a:rPr>
+                <a:solidFill/>
+              </a:rPr>
               <a:t>The following EA portfolios have no line items in this proposal:</a:t>
             </a:r>
           </a:p>
@@ -7862,11 +8458,14 @@
               </a:spcAft>
               <a:defRPr sz="1800">
                 <a:solidFill>
-                  <a:srgbClr val="333333"/>
-                </a:solidFill>
-              </a:defRPr>
-            </a:pPr>
-            <a:r>
+                  <a:srgbClr val="E0E0E0"/>
+                </a:solidFill>
+              </a:defRPr>
+            </a:pPr>
+            <a:r>
+              <a:rPr>
+                <a:solidFill/>
+              </a:rPr>
               <a:t>Collaboration (Webex, Calling, Contact Center)</a:t>
             </a:r>
           </a:p>
@@ -7877,11 +8476,14 @@
               </a:spcAft>
               <a:defRPr sz="1800">
                 <a:solidFill>
-                  <a:srgbClr val="333333"/>
-                </a:solidFill>
-              </a:defRPr>
-            </a:pPr>
-            <a:r>
+                  <a:srgbClr val="E0E0E0"/>
+                </a:solidFill>
+              </a:defRPr>
+            </a:pPr>
+            <a:r>
+              <a:rPr>
+                <a:solidFill/>
+              </a:rPr>
               <a:t>Hybrid Cloud</a:t>
             </a:r>
           </a:p>
@@ -7892,11 +8494,14 @@
               </a:spcAft>
               <a:defRPr sz="1800">
                 <a:solidFill>
-                  <a:srgbClr val="333333"/>
-                </a:solidFill>
-              </a:defRPr>
-            </a:pPr>
-            <a:r>
+                  <a:srgbClr val="E0E0E0"/>
+                </a:solidFill>
+              </a:defRPr>
+            </a:pPr>
+            <a:r>
+              <a:rPr>
+                <a:solidFill/>
+              </a:rPr>
               <a:t>Provider Connectivity</a:t>
             </a:r>
           </a:p>
@@ -7907,11 +8512,14 @@
               </a:spcAft>
               <a:defRPr sz="1800">
                 <a:solidFill>
-                  <a:srgbClr val="333333"/>
-                </a:solidFill>
-              </a:defRPr>
-            </a:pPr>
-            <a:r>
+                  <a:srgbClr val="E0E0E0"/>
+                </a:solidFill>
+              </a:defRPr>
+            </a:pPr>
+            <a:r>
+              <a:rPr>
+                <a:solidFill/>
+              </a:rPr>
               <a:t>Cisco Professional Services</a:t>
             </a:r>
           </a:p>
@@ -7922,7 +8530,7 @@
               </a:spcAft>
               <a:defRPr sz="1800">
                 <a:solidFill>
-                  <a:srgbClr val="333333"/>
+                  <a:srgbClr val="E0E0E0"/>
                 </a:solidFill>
               </a:defRPr>
             </a:pPr>
@@ -7934,11 +8542,14 @@
               </a:spcAft>
               <a:defRPr sz="1800">
                 <a:solidFill>
-                  <a:srgbClr val="333333"/>
-                </a:solidFill>
-              </a:defRPr>
-            </a:pPr>
-            <a:r>
+                  <a:srgbClr val="E0E0E0"/>
+                </a:solidFill>
+              </a:defRPr>
+            </a:pPr>
+            <a:r>
+              <a:rPr>
+                <a:solidFill/>
+              </a:rPr>
               <a:t>These can be added in future EA amendments if needed.</a:t>
             </a:r>
           </a:p>
@@ -7953,23 +8564,23 @@
 </file>
 
 <file path=ppt/theme/theme1.xml><?xml version="1.0" encoding="utf-8"?>
-<a:theme xmlns:a="http://schemas.openxmlformats.org/drawingml/2006/main" name="Office Theme">
+<a:theme xmlns:a="http://schemas.openxmlformats.org/drawingml/2006/main" name="Cisco Dark Theme">
   <a:themeElements>
-    <a:clrScheme name="Office">
+    <a:clrScheme name="Cisco Dark">
       <a:dk1>
-        <a:sysClr val="windowText" lastClr="000000"/>
+        <a:srgbClr val="E0E0E0"/>
       </a:dk1>
       <a:lt1>
-        <a:sysClr val="window" lastClr="FFFFFF"/>
+        <a:srgbClr val="1A2B4A"/>
       </a:lt1>
       <a:dk2>
-        <a:srgbClr val="1F497D"/>
+        <a:srgbClr val="007BC7"/>
       </a:dk2>
       <a:lt2>
-        <a:srgbClr val="EEECE1"/>
+        <a:srgbClr val="2D3A52"/>
       </a:lt2>
       <a:accent1>
-        <a:srgbClr val="4F81BD"/>
+        <a:srgbClr val="007BC7"/>
       </a:accent1>
       <a:accent2>
         <a:srgbClr val="C0504D"/>
@@ -7993,7 +8604,7 @@
         <a:srgbClr val="800080"/>
       </a:folHlink>
     </a:clrScheme>
-    <a:fontScheme name="Office">
+    <a:fontScheme name="Cisco Dark">
       <a:majorFont>
         <a:latin typeface="Calibri"/>
         <a:ea typeface=""/>
@@ -8065,7 +8676,7 @@
         <a:font script="Geor" typeface="Sylfaen"/>
       </a:minorFont>
     </a:fontScheme>
-    <a:fmtScheme name="Office">
+    <a:fmtScheme name="Cisco Dark">
       <a:fillStyleLst>
         <a:solidFill>
           <a:schemeClr val="phClr"/>

</xml_diff>